<commit_message>
Apply J11 remediation across paper, decks and notes: withdraw the residency mechanism, correct the per-dollar comparison to a consistent quoted-price basis, disclose the prefix-hit asymmetry, restrict Figure 9 to uncapped concurrencies, correct the Table 4 dispersion claim
</commit_message>
<xml_diff>
--- a/Gisting-CTO-deck.pptx
+++ b/Gisting-CTO-deck.pptx
@@ -4973,7 +4973,7 @@
                 </a:solidFill>
                 <a:latin typeface="Calibri"/>
               </a:rPr>
-              <a:t>▪  2x load within SLO, +44% peak on a tuned server, 3 repeats, 0 failures.</a:t>
+              <a:t>▪  Finite-window H100 replay: 2x target rate, +44% observed peak.</a:t>
             </a:r>
           </a:p>
           <a:p>
@@ -4992,7 +4992,7 @@
                 </a:solidFill>
                 <a:latin typeface="Calibri"/>
               </a:rPr>
-              <a:t>▪  Incremental over prefix caching (2–4x without it); mechanism measured.</a:t>
+              <a:t>▪  Cache-off advantage observed on H100; mechanism unestablished.</a:t>
             </a:r>
           </a:p>
           <a:p>
@@ -5011,7 +5011,7 @@
                 </a:solidFill>
                 <a:latin typeface="Calibri"/>
               </a:rPr>
-              <a:t>▪  Throughput per dollar on two GPU classes; the fix removes the path failure.</a:t>
+              <a:t>▪  Quoted-price comparison corrected; J11 withdraws the H200 ceiling explanation.</a:t>
             </a:r>
           </a:p>
         </p:txBody>
@@ -5120,7 +5120,7 @@
                 </a:solidFill>
                 <a:latin typeface="Calibri"/>
               </a:rPr>
-              <a:t>▪  Generalisation on unseen, held-out work.</a:t>
+              <a:t>▪  Generalisation, sustained capacity and savings on unseen work.</a:t>
             </a:r>
           </a:p>
           <a:p>
@@ -5545,7 +5545,7 @@
                 </a:solidFill>
                 <a:latin typeface="Calibri"/>
               </a:rPr>
-              <a:t>Re-tune the server for each GPU class and re-measure; the capacity number is now measured on the H100, and the H200 showed one regression from an H100-tuned config.</a:t>
+              <a:t>Tune both prompt versions on each GPU and re-measure with explicit admission limits. The current results are finite-window replay observations.</a:t>
             </a:r>
           </a:p>
         </p:txBody>
@@ -5677,7 +5677,7 @@
                 </a:solidFill>
                 <a:latin typeface="Calibri"/>
               </a:rPr>
-              <a:t>Bounded effort: a single GPU over days, not a new research program. The capacity number is measured; what remains is proof on work we did not design.</a:t>
+              <a:t>Validate quality and sustained performance before a pilot. J11 corrects one instrument defect; the other review findings remain open.</a:t>
             </a:r>
           </a:p>
         </p:txBody>
@@ -5823,7 +5823,7 @@
                 </a:solidFill>
                 <a:latin typeface="Georgia"/>
               </a:rPr>
-              <a:t>The lever is real and cheap to prototype</a:t>
+              <a:t>Validate the deployment case</a:t>
             </a:r>
           </a:p>
         </p:txBody>
@@ -5865,7 +5865,7 @@
                 </a:solidFill>
                 <a:latin typeface="Georgia"/>
               </a:rPr>
-              <a:t>The capacity number is measured. Fund the held-out validation and a guarded pilot.</a:t>
+              <a:t>Fund validation of quality, sustained performance and cost before a guarded pilot.</a:t>
             </a:r>
           </a:p>
         </p:txBody>
@@ -5907,7 +5907,7 @@
                 </a:solidFill>
                 <a:latin typeface="Calibri"/>
               </a:rPr>
-              <a:t>The tooling exists, the risk is contained, and the upside is measured: 2x the load within SLO on the same GPU, or the same throughput per dollar from a cheaper GPU. What’s missing is proof on unseen work, and that is days of work away, not months.</a:t>
+              <a:t>H100 replay recorded 2x the target rate passing the latency criterion and +44% observed peak throughput. J11 withdrew the residency explanation. The corrected cost comparison does not establish cheaper-card substitution. Those open questions determine the next experiment.</a:t>
             </a:r>
           </a:p>
         </p:txBody>
@@ -7255,7 +7255,7 @@
                 </a:solidFill>
                 <a:latin typeface="Calibri"/>
               </a:rPr>
-              <a:t>2x the request rate within the latency SLO and +44% peak throughput on the same GPU (tuned server, 3 repeats). A cost lever: a cheaper GPU with gist matched a pricier one per dollar.</a:t>
+              <a:t>H100 finite-window replay: 2x the target rate passing the latency criterion and +44% observed peak throughput. Mechanism and deployment savings remain unestablished.</a:t>
             </a:r>
           </a:p>
         </p:txBody>
@@ -7684,7 +7684,7 @@
                 </a:solidFill>
                 <a:latin typeface="Calibri"/>
               </a:rPr>
-              <a:t>Token-bound. Fewer input tokens per turn → each session finishes sooner → more load per GPU before latency degrades. Measured: 2x at the SLO.</a:t>
+              <a:t>Shorter prompts change the work the server performs. Mechanism and deployment value remain open. Replay: 2x the target rate passed the chosen criterion.</a:t>
             </a:r>
           </a:p>
         </p:txBody>
@@ -10171,7 +10171,7 @@
                 </a:solidFill>
                 <a:latin typeface="Georgia"/>
               </a:rPr>
-              <a:t>The saving shows up as capacity under load</a:t>
+              <a:t>Finite-window serving measurements</a:t>
             </a:r>
           </a:p>
         </p:txBody>
@@ -10250,7 +10250,7 @@
                 </a:solidFill>
                 <a:latin typeface="Consolas"/>
               </a:rPr>
-              <a:t>request rate within the latency SLO (18 → 36 req/min, random arrivals)</a:t>
+              <a:t>target rate passing the latency criterion (18 → 36 req/min)</a:t>
             </a:r>
           </a:p>
           <a:p>
@@ -10307,7 +10307,7 @@
                 </a:solidFill>
                 <a:latin typeface="Calibri"/>
               </a:rPr>
-              <a:t>The advantage grows with load (1.12x at 1 session → 1.65x at 48) and is incremental over prefix caching: 2–4x larger when caching can't help. 201 runs, 0 failures.</a:t>
+              <a:t>The advantage grows with load (1.12x at 1 session → 1.65x at 48) and is incremental over prefix caching: 2–4x larger when caching can't help. J10: 202 runs across both GPUs, 0 request errors.</a:t>
             </a:r>
           </a:p>
         </p:txBody>
@@ -10411,7 +10411,7 @@
                 </a:solidFill>
                 <a:latin typeface="Consolas"/>
               </a:rPr>
-              <a:t>THE CATCH · ARCHITECTURE</a:t>
+              <a:t>CORRECTION · J11</a:t>
             </a:r>
           </a:p>
         </p:txBody>
@@ -10453,7 +10453,7 @@
                 </a:solidFill>
                 <a:latin typeface="Georgia"/>
               </a:rPr>
-              <a:t>Why it’s capacity, not speed</a:t>
+              <a:t>The residency explanation was wrong</a:t>
             </a:r>
           </a:p>
         </p:txBody>
@@ -10495,7 +10495,7 @@
                 </a:solidFill>
                 <a:latin typeface="Calibri"/>
               </a:rPr>
-              <a:t>This model uses full attention in only 16 of its 64 layers, and the number of sessions it can hold at once is set by a fixed per-session state, not by prompt length. A shorter prompt does not fit many more sessions; it makes each session finish sooner. The win is throughput under load, not a faster single answer.</a:t>
+              <a:t>External review found a 100-connection limit in our load generator. J11 removed it and measured 123 to 137 simultaneous requests on the H200. We withdrew the hardware-ceiling explanation. The cause of the throughput difference remains under investigation.</a:t>
             </a:r>
           </a:p>
         </p:txBody>
@@ -13452,8 +13452,8 @@
         </p:nvSpPr>
         <p:spPr>
           <a:xfrm>
-            <a:off x="640080" y="5394960"/>
-            <a:ext cx="10607040" cy="822960"/>
+            <a:off x="640080" y="5303520"/>
+            <a:ext cx="10607040" cy="1051560"/>
           </a:xfrm>
           <a:prstGeom prst="rect">
             <a:avLst/>
@@ -13468,7 +13468,7 @@
           <a:p>
             <a:pPr algn="l">
               <a:lnSpc>
-                <a:spcPct val="120000"/>
+                <a:spcPct val="115000"/>
               </a:lnSpc>
               <a:spcAft>
                 <a:spcPts val="0"/>
@@ -13481,7 +13481,7 @@
                 </a:solidFill>
                 <a:latin typeface="Calibri"/>
               </a:rPr>
-              <a:t>■ full-attention layers      ■ linear-attention layers (fixed-size state).  Measured: at the resident-session ceiling both arms hold the same number of sessions; the gist turns them over faster (H200: 85 vs 50 req/min at 100 resident).</a:t>
+              <a:t>Architecture: 16 full-attention layers and 48 linear-attention layers. This diagram does not establish a residency mechanism. J11 measured 137 gist versus 126 full at 256 offered requests, with nearly full cache. Lifting the cap reduced throughput in three of four comparisons. One run per condition; no quality test.</a:t>
             </a:r>
           </a:p>
         </p:txBody>
@@ -13585,7 +13585,7 @@
                 </a:solidFill>
                 <a:latin typeface="Consolas"/>
               </a:rPr>
-              <a:t>THE COST LEVER</a:t>
+              <a:t>CORRECTED COST COMPARISON</a:t>
             </a:r>
           </a:p>
         </p:txBody>
@@ -13627,7 +13627,7 @@
                 </a:solidFill>
                 <a:latin typeface="Georgia"/>
               </a:rPr>
-              <a:t>Gisting lets a cheaper GPU match a pricier one</a:t>
+              <a:t>Similar replay output per rental dollar</a:t>
             </a:r>
           </a:p>
         </p:txBody>
@@ -13669,7 +13669,7 @@
                 </a:solidFill>
                 <a:latin typeface="Consolas"/>
               </a:rPr>
-              <a:t>16.2</a:t>
+              <a:t>16.16</a:t>
             </a:r>
           </a:p>
         </p:txBody>
@@ -13753,7 +13753,7 @@
                 </a:solidFill>
                 <a:latin typeface="Consolas"/>
               </a:rPr>
-              <a:t>23.2</a:t>
+              <a:t>23.23</a:t>
             </a:r>
           </a:p>
         </p:txBody>
@@ -13837,7 +13837,7 @@
                 </a:solidFill>
                 <a:latin typeface="Consolas"/>
               </a:rPr>
-              <a:t>22.5</a:t>
+              <a:t>23.38</a:t>
             </a:r>
           </a:p>
         </p:txBody>
@@ -13921,7 +13921,7 @@
                 </a:solidFill>
                 <a:latin typeface="Consolas"/>
               </a:rPr>
-              <a:t>22.0</a:t>
+              <a:t>22.83</a:t>
             </a:r>
           </a:p>
         </p:txBody>
@@ -14005,7 +14005,7 @@
                 </a:solidFill>
                 <a:latin typeface="Consolas"/>
               </a:rPr>
-              <a:t>peak requests per minute, per dollar-hour of GPU rental (spot prices on the day of the run)</a:t>
+              <a:t>peak replay req/min per ($/h), quoted prices: H100 $2.64/h; H200 $3.65/h</a:t>
             </a:r>
           </a:p>
         </p:txBody>
@@ -14019,7 +14019,7 @@
         <p:spPr>
           <a:xfrm>
             <a:off x="640080" y="3840480"/>
-            <a:ext cx="10881360" cy="1280160"/>
+            <a:ext cx="10881360" cy="1143000"/>
           </a:xfrm>
           <a:prstGeom prst="rect">
             <a:avLst/>
@@ -14047,7 +14047,7 @@
                 </a:solidFill>
                 <a:latin typeface="Calibri"/>
               </a:rPr>
-              <a:t>On the bigger H200 (143 GB), gist's peak gain vanished at normal load (-2%) and appeared only under pressure (3.1x at 128 sessions). On the H100 (95 GB) it was +44%. The benefit is proportional to how memory-constrained the hardware is relative to the prompt.</a:t>
+              <a:t>H200 with the full prompt gives 23.38, slightly above H100 with gist at 23.23. Earlier figures mixed quoted and effective prices. Cheaper-card substitution is not established.</a:t>
             </a:r>
           </a:p>
         </p:txBody>
@@ -14060,8 +14060,8 @@
         </p:nvSpPr>
         <p:spPr>
           <a:xfrm>
-            <a:off x="640080" y="5303520"/>
-            <a:ext cx="10881360" cy="914400"/>
+            <a:off x="640080" y="5166360"/>
+            <a:ext cx="10881360" cy="1097280"/>
           </a:xfrm>
           <a:prstGeom prst="rect">
             <a:avLst/>
@@ -14076,7 +14076,7 @@
           <a:p>
             <a:pPr algn="l">
               <a:lnSpc>
-                <a:spcPct val="120000"/>
+                <a:spcPct val="115000"/>
               </a:lnSpc>
               <a:spcAft>
                 <a:spcPts val="0"/>
@@ -14089,7 +14089,7 @@
                 </a:solidFill>
                 <a:latin typeface="Calibri"/>
               </a:rPr>
-              <a:t>Read it as a cost lever, not a speed lever: gist on the cheaper card delivers the expensive card's throughput per dollar. Where prompts don't share prefixes (no cache help), gist's 2–4x advantage holds on any card.</a:t>
+              <a:t>These peaks are finite-window replay measurements, with unequal hardware tuning and no quality test at load. Prefix-cache hit rates also differ: full 0.791 to 0.840, gist 0.580 to 0.626 in J11. The higher cached fraction favours full on that metric; its effect on the comparison was not controlled.</a:t>
             </a:r>
           </a:p>
         </p:txBody>

</xml_diff>

<commit_message>
Deck: remove inferred pillar integrations; keep distil-then-gist as the one synergy, inner loop as a proposal, span study per harness and distilled-model pair
</commit_message>
<xml_diff>
--- a/Gisting-CTO-deck.pptx
+++ b/Gisting-CTO-deck.pptx
@@ -4076,7 +4076,7 @@
                 </a:solidFill>
                 <a:latin typeface="Calibri"/>
               </a:rPr>
-              <a:t>▪  A second harness and model pairing, including its span study.</a:t>
+              <a:t>▪  The experiment suite on a second harness and distilled-model pair.</a:t>
             </a:r>
           </a:p>
           <a:p>
@@ -5395,7 +5395,7 @@
                 </a:solidFill>
                 <a:latin typeface="Consolas"/>
               </a:rPr>
-              <a:t>1 · SECOND PAIRING</a:t>
+              <a:t>1 · NEXT PAIR</a:t>
             </a:r>
           </a:p>
           <a:p>
@@ -5414,7 +5414,7 @@
                 </a:solidFill>
                 <a:latin typeface="Calibri"/>
               </a:rPr>
-              <a:t>A Jetstream inner-loop harness on an open-weights model, through the meta-harness, starting with its span study. Proves the recipe carries.</a:t>
+              <a:t>Run the experiment suite, span study first, on the next harness and distilled-model pair. Shows the recipe carries.</a:t>
             </a:r>
           </a:p>
         </p:txBody>
@@ -5632,7 +5632,7 @@
                 </a:solidFill>
                 <a:latin typeface="Calibri"/>
               </a:rPr>
-              <a:t>Inner loop, behind the meta-harness, with an automatic fallback to the full prompt.</a:t>
+              <a:t>Proposed for the Jetstream inner loop, with rule-audit and write-target checks at the serving boundary.</a:t>
             </a:r>
           </a:p>
         </p:txBody>
@@ -5668,13 +5668,13 @@
               </a:spcAft>
             </a:pPr>
             <a:r>
-              <a:rPr sz="2600" b="1">
+              <a:rPr sz="2400" b="1">
                 <a:solidFill>
                   <a:srgbClr val="FFFFFF"/>
                 </a:solidFill>
                 <a:latin typeface="Georgia"/>
               </a:rPr>
-              <a:t>The lever is real on one pairing. The next step is showing it travels.</a:t>
+              <a:t>The lever is real on one pairing. Next, show it carries to a distilled model on another harness.</a:t>
             </a:r>
           </a:p>
         </p:txBody>
@@ -10346,7 +10346,7 @@
                 </a:solidFill>
                 <a:latin typeface="Calibri"/>
               </a:rPr>
-              <a:t>Every new pairing will hit this boundary. It is also why memory and gisting are complementary rather than overlapping.</a:t>
+              <a:t>Every new harness and model pair will hit this boundary, which is why the span study comes first.</a:t>
             </a:r>
           </a:p>
         </p:txBody>
@@ -10601,7 +10601,7 @@
                 </a:solidFill>
                 <a:latin typeface="Calibri"/>
               </a:rPr>
-              <a:t>A fourth Lattice lever. Routing and distillation cut cost per token; the meta-harness shapes calls. Gisting cuts the fixed tokens every call carries.</a:t>
+              <a:t>A new pillar under Lattice, alongside the meta-harness, adaptive routing and model distillation tracks. Gisting cuts the fixed prompt a coding agent re-sends on every call.</a:t>
             </a:r>
           </a:p>
         </p:txBody>
@@ -10928,7 +10928,7 @@
                 </a:solidFill>
                 <a:latin typeface="Calibri"/>
               </a:rPr>
-              <a:t>Take the recipe to a second harness and model pairing through the meta-harness, validate on held-out work, then a guarded pilot.</a:t>
+              <a:t>Run the same experiment suite on the next harness and distilled-model pair, validate on held-out work, then a guarded pilot.</a:t>
             </a:r>
           </a:p>
         </p:txBody>
@@ -11032,7 +11032,7 @@
                 </a:solidFill>
                 <a:latin typeface="Consolas"/>
               </a:rPr>
-              <a:t>WHERE GISTING SITS IN LATTICE</a:t>
+              <a:t>LATTICE · COST OPTIMIZATION</a:t>
             </a:r>
           </a:p>
         </p:txBody>
@@ -11074,21 +11074,63 @@
                 </a:solidFill>
                 <a:latin typeface="Georgia"/>
               </a:rPr>
-              <a:t>Four levers on one cost equation</a:t>
-            </a:r>
-          </a:p>
-        </p:txBody>
-      </p:sp>
-      <p:sp>
-        <p:nvSpPr>
-          <p:cNvPr id="5" name="Rounded Rectangle 4"/>
+              <a:t>A new pillar under Lattice</a:t>
+            </a:r>
+          </a:p>
+        </p:txBody>
+      </p:sp>
+      <p:sp>
+        <p:nvSpPr>
+          <p:cNvPr id="5" name="TextBox 4"/>
+          <p:cNvSpPr txBox="1"/>
+          <p:nvPr/>
+        </p:nvSpPr>
+        <p:spPr>
+          <a:xfrm>
+            <a:off x="640080" y="1828800"/>
+            <a:ext cx="10607040" cy="822960"/>
+          </a:xfrm>
+          <a:prstGeom prst="rect">
+            <a:avLst/>
+          </a:prstGeom>
+          <a:noFill/>
+        </p:spPr>
+        <p:txBody>
+          <a:bodyPr wrap="square" anchor="t">
+            <a:spAutoFit/>
+          </a:bodyPr>
+          <a:lstStyle/>
+          <a:p>
+            <a:pPr algn="l">
+              <a:lnSpc>
+                <a:spcPct val="120000"/>
+              </a:lnSpc>
+              <a:spcAft>
+                <a:spcPts val="0"/>
+              </a:spcAft>
+            </a:pPr>
+            <a:r>
+              <a:rPr sz="1700" b="0">
+                <a:solidFill>
+                  <a:srgbClr val="9FB2B6"/>
+                </a:solidFill>
+                <a:latin typeface="Calibri"/>
+              </a:rPr>
+              <a:t>Gisting’s lever on total cost: the model reads fewer tokens on every agent call, so the same GPU does more work.</a:t>
+            </a:r>
+          </a:p>
+        </p:txBody>
+      </p:sp>
+      <p:sp>
+        <p:nvSpPr>
+          <p:cNvPr id="6" name="Rounded Rectangle 5"/>
           <p:cNvSpPr/>
           <p:nvPr/>
         </p:nvSpPr>
         <p:spPr>
           <a:xfrm>
-            <a:off x="640080" y="1874519"/>
-            <a:ext cx="2116836" cy="548640"/>
+            <a:off x="640080" y="2926080"/>
+            <a:ext cx="2583180" cy="2194560"/>
           </a:xfrm>
           <a:prstGeom prst="roundRect">
             <a:avLst>
@@ -11129,14 +11171,14 @@
       </p:sp>
       <p:sp>
         <p:nvSpPr>
-          <p:cNvPr id="6" name="TextBox 5"/>
+          <p:cNvPr id="7" name="TextBox 6"/>
           <p:cNvSpPr txBox="1"/>
           <p:nvPr/>
         </p:nvSpPr>
         <p:spPr>
           <a:xfrm>
-            <a:off x="640080" y="1874519"/>
-            <a:ext cx="2116836" cy="548640"/>
+            <a:off x="896112" y="3145536"/>
+            <a:ext cx="2071116" cy="1755648"/>
           </a:xfrm>
           <a:prstGeom prst="rect">
             <a:avLst/>
@@ -11144,69 +11186,46 @@
           <a:noFill/>
         </p:spPr>
         <p:txBody>
-          <a:bodyPr wrap="square" anchor="ctr">
+          <a:bodyPr wrap="square" anchor="t">
             <a:spAutoFit/>
           </a:bodyPr>
           <a:lstStyle/>
           <a:p>
-            <a:pPr algn="ctr">
+            <a:pPr algn="l">
               <a:lnSpc>
                 <a:spcPct val="100000"/>
               </a:lnSpc>
               <a:spcAft>
+                <a:spcPts val="600"/>
+              </a:spcAft>
+            </a:pPr>
+            <a:r>
+              <a:rPr sz="1100" b="1">
+                <a:solidFill>
+                  <a:srgbClr val="3FB0C6"/>
+                </a:solidFill>
+                <a:latin typeface="Consolas"/>
+              </a:rPr>
+              <a:t>META-HARNESS</a:t>
+            </a:r>
+          </a:p>
+          <a:p>
+            <a:pPr algn="l">
+              <a:lnSpc>
+                <a:spcPct val="115000"/>
+              </a:lnSpc>
+              <a:spcAft>
                 <a:spcPts val="0"/>
               </a:spcAft>
             </a:pPr>
             <a:r>
-              <a:rPr sz="1600" b="0">
+              <a:rPr sz="1500" b="0">
                 <a:solidFill>
                   <a:srgbClr val="EEF3F3"/>
                 </a:solidFill>
-                <a:latin typeface="Consolas"/>
-              </a:rPr>
-              <a:t>cost per task</a:t>
-            </a:r>
-          </a:p>
-        </p:txBody>
-      </p:sp>
-      <p:sp>
-        <p:nvSpPr>
-          <p:cNvPr id="7" name="TextBox 6"/>
-          <p:cNvSpPr txBox="1"/>
-          <p:nvPr/>
-        </p:nvSpPr>
-        <p:spPr>
-          <a:xfrm>
-            <a:off x="2848356" y="1874519"/>
-            <a:ext cx="411480" cy="548640"/>
-          </a:xfrm>
-          <a:prstGeom prst="rect">
-            <a:avLst/>
-          </a:prstGeom>
-          <a:noFill/>
-        </p:spPr>
-        <p:txBody>
-          <a:bodyPr wrap="square" anchor="ctr">
-            <a:spAutoFit/>
-          </a:bodyPr>
-          <a:lstStyle/>
-          <a:p>
-            <a:pPr algn="ctr">
-              <a:lnSpc>
-                <a:spcPct val="100000"/>
-              </a:lnSpc>
-              <a:spcAft>
-                <a:spcPts val="0"/>
-              </a:spcAft>
-            </a:pPr>
-            <a:r>
-              <a:rPr sz="2000" b="1">
-                <a:solidFill>
-                  <a:srgbClr val="3FB0C6"/>
-                </a:solidFill>
-                <a:latin typeface="Consolas"/>
-              </a:rPr>
-              <a:t>=</a:t>
+                <a:latin typeface="Calibri"/>
+              </a:rPr>
+              <a:t>Adapter that routes different harnesses to underlying models.</a:t>
             </a:r>
           </a:p>
         </p:txBody>
@@ -11219,8 +11238,8 @@
         </p:nvSpPr>
         <p:spPr>
           <a:xfrm>
-            <a:off x="3259836" y="1874519"/>
-            <a:ext cx="982980" cy="548640"/>
+            <a:off x="3406140" y="2926080"/>
+            <a:ext cx="2583180" cy="2194560"/>
           </a:xfrm>
           <a:prstGeom prst="roundRect">
             <a:avLst>
@@ -11267,8 +11286,8 @@
         </p:nvSpPr>
         <p:spPr>
           <a:xfrm>
-            <a:off x="3259836" y="1874519"/>
-            <a:ext cx="982980" cy="548640"/>
+            <a:off x="3662172" y="3145536"/>
+            <a:ext cx="2071116" cy="1755648"/>
           </a:xfrm>
           <a:prstGeom prst="rect">
             <a:avLst/>
@@ -11276,215 +11295,60 @@
           <a:noFill/>
         </p:spPr>
         <p:txBody>
-          <a:bodyPr wrap="square" anchor="ctr">
+          <a:bodyPr wrap="square" anchor="t">
             <a:spAutoFit/>
           </a:bodyPr>
           <a:lstStyle/>
           <a:p>
-            <a:pPr algn="ctr">
+            <a:pPr algn="l">
               <a:lnSpc>
                 <a:spcPct val="100000"/>
               </a:lnSpc>
               <a:spcAft>
+                <a:spcPts val="600"/>
+              </a:spcAft>
+            </a:pPr>
+            <a:r>
+              <a:rPr sz="1100" b="1">
+                <a:solidFill>
+                  <a:srgbClr val="3FB0C6"/>
+                </a:solidFill>
+                <a:latin typeface="Consolas"/>
+              </a:rPr>
+              <a:t>ADAPTIVE ROUTING</a:t>
+            </a:r>
+          </a:p>
+          <a:p>
+            <a:pPr algn="l">
+              <a:lnSpc>
+                <a:spcPct val="115000"/>
+              </a:lnSpc>
+              <a:spcAft>
                 <a:spcPts val="0"/>
               </a:spcAft>
             </a:pPr>
             <a:r>
-              <a:rPr sz="1600" b="0">
+              <a:rPr sz="1500" b="0">
                 <a:solidFill>
                   <a:srgbClr val="EEF3F3"/>
                 </a:solidFill>
-                <a:latin typeface="Consolas"/>
-              </a:rPr>
-              <a:t>calls</a:t>
-            </a:r>
-          </a:p>
-        </p:txBody>
-      </p:sp>
-      <p:sp>
-        <p:nvSpPr>
-          <p:cNvPr id="10" name="TextBox 9"/>
-          <p:cNvSpPr txBox="1"/>
-          <p:nvPr/>
-        </p:nvSpPr>
-        <p:spPr>
-          <a:xfrm>
-            <a:off x="4334256" y="1874519"/>
-            <a:ext cx="411480" cy="548640"/>
-          </a:xfrm>
-          <a:prstGeom prst="rect">
-            <a:avLst/>
-          </a:prstGeom>
-          <a:noFill/>
-        </p:spPr>
-        <p:txBody>
-          <a:bodyPr wrap="square" anchor="ctr">
-            <a:spAutoFit/>
-          </a:bodyPr>
-          <a:lstStyle/>
-          <a:p>
-            <a:pPr algn="ctr">
-              <a:lnSpc>
-                <a:spcPct val="100000"/>
-              </a:lnSpc>
-              <a:spcAft>
-                <a:spcPts val="0"/>
-              </a:spcAft>
-            </a:pPr>
-            <a:r>
-              <a:rPr sz="2000" b="1">
-                <a:solidFill>
-                  <a:srgbClr val="3FB0C6"/>
-                </a:solidFill>
-                <a:latin typeface="Consolas"/>
-              </a:rPr>
-              <a:t>×</a:t>
-            </a:r>
-          </a:p>
-        </p:txBody>
-      </p:sp>
-      <p:sp>
-        <p:nvSpPr>
-          <p:cNvPr id="11" name="Rounded Rectangle 10"/>
+                <a:latin typeface="Calibri"/>
+              </a:rPr>
+              <a:t>Research track.</a:t>
+            </a:r>
+          </a:p>
+        </p:txBody>
+      </p:sp>
+      <p:sp>
+        <p:nvSpPr>
+          <p:cNvPr id="10" name="Rounded Rectangle 9"/>
           <p:cNvSpPr/>
           <p:nvPr/>
         </p:nvSpPr>
         <p:spPr>
           <a:xfrm>
-            <a:off x="4745736" y="1874519"/>
-            <a:ext cx="2400300" cy="548640"/>
-          </a:xfrm>
-          <a:prstGeom prst="roundRect">
-            <a:avLst>
-              <a:gd name="adj" fmla="val 6000"/>
-            </a:avLst>
-          </a:prstGeom>
-          <a:solidFill>
-            <a:srgbClr val="141D21"/>
-          </a:solidFill>
-          <a:ln w="12700">
-            <a:solidFill>
-              <a:srgbClr val="5A3F6E"/>
-            </a:solidFill>
-          </a:ln>
-          <a:effectLst/>
-        </p:spPr>
-        <p:style>
-          <a:lnRef idx="1">
-            <a:schemeClr val="accent1"/>
-          </a:lnRef>
-          <a:fillRef idx="3">
-            <a:schemeClr val="accent1"/>
-          </a:fillRef>
-          <a:effectRef idx="2">
-            <a:schemeClr val="accent1"/>
-          </a:effectRef>
-          <a:fontRef idx="minor">
-            <a:schemeClr val="lt1"/>
-          </a:fontRef>
-        </p:style>
-        <p:txBody>
-          <a:bodyPr rtlCol="0" anchor="ctr"/>
-          <a:lstStyle/>
-          <a:p>
-            <a:pPr algn="ctr"/>
-          </a:p>
-        </p:txBody>
-      </p:sp>
-      <p:sp>
-        <p:nvSpPr>
-          <p:cNvPr id="12" name="TextBox 11"/>
-          <p:cNvSpPr txBox="1"/>
-          <p:nvPr/>
-        </p:nvSpPr>
-        <p:spPr>
-          <a:xfrm>
-            <a:off x="4745736" y="1874519"/>
-            <a:ext cx="2400300" cy="548640"/>
-          </a:xfrm>
-          <a:prstGeom prst="rect">
-            <a:avLst/>
-          </a:prstGeom>
-          <a:noFill/>
-        </p:spPr>
-        <p:txBody>
-          <a:bodyPr wrap="square" anchor="ctr">
-            <a:spAutoFit/>
-          </a:bodyPr>
-          <a:lstStyle/>
-          <a:p>
-            <a:pPr algn="ctr">
-              <a:lnSpc>
-                <a:spcPct val="100000"/>
-              </a:lnSpc>
-              <a:spcAft>
-                <a:spcPts val="0"/>
-              </a:spcAft>
-            </a:pPr>
-            <a:r>
-              <a:rPr sz="1600" b="0">
-                <a:solidFill>
-                  <a:srgbClr val="C39BE0"/>
-                </a:solidFill>
-                <a:latin typeface="Consolas"/>
-              </a:rPr>
-              <a:t>tokens per call</a:t>
-            </a:r>
-          </a:p>
-        </p:txBody>
-      </p:sp>
-      <p:sp>
-        <p:nvSpPr>
-          <p:cNvPr id="13" name="TextBox 12"/>
-          <p:cNvSpPr txBox="1"/>
-          <p:nvPr/>
-        </p:nvSpPr>
-        <p:spPr>
-          <a:xfrm>
-            <a:off x="7237476" y="1874519"/>
-            <a:ext cx="411480" cy="548640"/>
-          </a:xfrm>
-          <a:prstGeom prst="rect">
-            <a:avLst/>
-          </a:prstGeom>
-          <a:noFill/>
-        </p:spPr>
-        <p:txBody>
-          <a:bodyPr wrap="square" anchor="ctr">
-            <a:spAutoFit/>
-          </a:bodyPr>
-          <a:lstStyle/>
-          <a:p>
-            <a:pPr algn="ctr">
-              <a:lnSpc>
-                <a:spcPct val="100000"/>
-              </a:lnSpc>
-              <a:spcAft>
-                <a:spcPts val="0"/>
-              </a:spcAft>
-            </a:pPr>
-            <a:r>
-              <a:rPr sz="2000" b="1">
-                <a:solidFill>
-                  <a:srgbClr val="3FB0C6"/>
-                </a:solidFill>
-                <a:latin typeface="Consolas"/>
-              </a:rPr>
-              <a:t>×</a:t>
-            </a:r>
-          </a:p>
-        </p:txBody>
-      </p:sp>
-      <p:sp>
-        <p:nvSpPr>
-          <p:cNvPr id="14" name="Rounded Rectangle 13"/>
-          <p:cNvSpPr/>
-          <p:nvPr/>
-        </p:nvSpPr>
-        <p:spPr>
-          <a:xfrm>
-            <a:off x="7648956" y="1874519"/>
-            <a:ext cx="2258568" cy="548640"/>
+            <a:off x="6172200" y="2926080"/>
+            <a:ext cx="2583180" cy="2194560"/>
           </a:xfrm>
           <a:prstGeom prst="roundRect">
             <a:avLst>
@@ -11525,104 +11389,14 @@
       </p:sp>
       <p:sp>
         <p:nvSpPr>
-          <p:cNvPr id="15" name="TextBox 14"/>
+          <p:cNvPr id="11" name="TextBox 10"/>
           <p:cNvSpPr txBox="1"/>
           <p:nvPr/>
         </p:nvSpPr>
         <p:spPr>
           <a:xfrm>
-            <a:off x="7648956" y="1874519"/>
-            <a:ext cx="2258568" cy="548640"/>
-          </a:xfrm>
-          <a:prstGeom prst="rect">
-            <a:avLst/>
-          </a:prstGeom>
-          <a:noFill/>
-        </p:spPr>
-        <p:txBody>
-          <a:bodyPr wrap="square" anchor="ctr">
-            <a:spAutoFit/>
-          </a:bodyPr>
-          <a:lstStyle/>
-          <a:p>
-            <a:pPr algn="ctr">
-              <a:lnSpc>
-                <a:spcPct val="100000"/>
-              </a:lnSpc>
-              <a:spcAft>
-                <a:spcPts val="0"/>
-              </a:spcAft>
-            </a:pPr>
-            <a:r>
-              <a:rPr sz="1600" b="0">
-                <a:solidFill>
-                  <a:srgbClr val="EEF3F3"/>
-                </a:solidFill>
-                <a:latin typeface="Consolas"/>
-              </a:rPr>
-              <a:t>cost per token</a:t>
-            </a:r>
-          </a:p>
-        </p:txBody>
-      </p:sp>
-      <p:sp>
-        <p:nvSpPr>
-          <p:cNvPr id="16" name="Rounded Rectangle 15"/>
-          <p:cNvSpPr/>
-          <p:nvPr/>
-        </p:nvSpPr>
-        <p:spPr>
-          <a:xfrm>
-            <a:off x="640080" y="2743200"/>
-            <a:ext cx="2583180" cy="2651760"/>
-          </a:xfrm>
-          <a:prstGeom prst="roundRect">
-            <a:avLst>
-              <a:gd name="adj" fmla="val 6000"/>
-            </a:avLst>
-          </a:prstGeom>
-          <a:solidFill>
-            <a:srgbClr val="141D21"/>
-          </a:solidFill>
-          <a:ln w="12700">
-            <a:solidFill>
-              <a:srgbClr val="25333A"/>
-            </a:solidFill>
-          </a:ln>
-          <a:effectLst/>
-        </p:spPr>
-        <p:style>
-          <a:lnRef idx="1">
-            <a:schemeClr val="accent1"/>
-          </a:lnRef>
-          <a:fillRef idx="3">
-            <a:schemeClr val="accent1"/>
-          </a:fillRef>
-          <a:effectRef idx="2">
-            <a:schemeClr val="accent1"/>
-          </a:effectRef>
-          <a:fontRef idx="minor">
-            <a:schemeClr val="lt1"/>
-          </a:fontRef>
-        </p:style>
-        <p:txBody>
-          <a:bodyPr rtlCol="0" anchor="ctr"/>
-          <a:lstStyle/>
-          <a:p>
-            <a:pPr algn="ctr"/>
-          </a:p>
-        </p:txBody>
-      </p:sp>
-      <p:sp>
-        <p:nvSpPr>
-          <p:cNvPr id="17" name="TextBox 16"/>
-          <p:cNvSpPr txBox="1"/>
-          <p:nvPr/>
-        </p:nvSpPr>
-        <p:spPr>
-          <a:xfrm>
-            <a:off x="896112" y="2962656"/>
-            <a:ext cx="2071116" cy="2212848"/>
+            <a:off x="6428232" y="3145536"/>
+            <a:ext cx="2071116" cy="1755648"/>
           </a:xfrm>
           <a:prstGeom prst="rect">
             <a:avLst/>
@@ -11650,31 +11424,12 @@
                 </a:solidFill>
                 <a:latin typeface="Consolas"/>
               </a:rPr>
-              <a:t>LATTICE META-HARNESS</a:t>
+              <a:t>MODEL DISTILLATION</a:t>
             </a:r>
           </a:p>
           <a:p>
             <a:pPr algn="l">
               <a:lnSpc>
-                <a:spcPct val="100000"/>
-              </a:lnSpc>
-              <a:spcAft>
-                <a:spcPts val="600"/>
-              </a:spcAft>
-            </a:pPr>
-            <a:r>
-              <a:rPr sz="1100" b="0">
-                <a:solidFill>
-                  <a:srgbClr val="9FB2B6"/>
-                </a:solidFill>
-                <a:latin typeface="Consolas"/>
-              </a:rPr>
-              <a:t>calls · where they land</a:t>
-            </a:r>
-          </a:p>
-          <a:p>
-            <a:pPr algn="l">
-              <a:lnSpc>
                 <a:spcPct val="115000"/>
               </a:lnSpc>
               <a:spcAft>
@@ -11682,27 +11437,27 @@
               </a:spcAft>
             </a:pPr>
             <a:r>
-              <a:rPr sz="1400" b="0">
+              <a:rPr sz="1500" b="0">
                 <a:solidFill>
                   <a:srgbClr val="EEF3F3"/>
                 </a:solidFill>
                 <a:latin typeface="Calibri"/>
               </a:rPr>
-              <a:t>One adapter from any harness to any model. The control point for how calls are made and which model serves them.</a:t>
-            </a:r>
-          </a:p>
-        </p:txBody>
-      </p:sp>
-      <p:sp>
-        <p:nvSpPr>
-          <p:cNvPr id="18" name="Rounded Rectangle 17"/>
+              <a:t>Research track.</a:t>
+            </a:r>
+          </a:p>
+        </p:txBody>
+      </p:sp>
+      <p:sp>
+        <p:nvSpPr>
+          <p:cNvPr id="12" name="Rounded Rectangle 11"/>
           <p:cNvSpPr/>
           <p:nvPr/>
         </p:nvSpPr>
         <p:spPr>
           <a:xfrm>
-            <a:off x="3406140" y="2743200"/>
-            <a:ext cx="2583180" cy="2651760"/>
+            <a:off x="8938260" y="2926080"/>
+            <a:ext cx="2583180" cy="2194560"/>
           </a:xfrm>
           <a:prstGeom prst="roundRect">
             <a:avLst>
@@ -11743,14 +11498,14 @@
       </p:sp>
       <p:sp>
         <p:nvSpPr>
-          <p:cNvPr id="19" name="TextBox 18"/>
+          <p:cNvPr id="13" name="TextBox 12"/>
           <p:cNvSpPr txBox="1"/>
           <p:nvPr/>
         </p:nvSpPr>
         <p:spPr>
           <a:xfrm>
-            <a:off x="3662172" y="2962656"/>
-            <a:ext cx="2071116" cy="2212848"/>
+            <a:off x="9194292" y="3145536"/>
+            <a:ext cx="2071116" cy="1755648"/>
           </a:xfrm>
           <a:prstGeom prst="rect">
             <a:avLst/>
@@ -11778,31 +11533,12 @@
                 </a:solidFill>
                 <a:latin typeface="Consolas"/>
               </a:rPr>
-              <a:t>GISTING · THIS PILLAR</a:t>
+              <a:t>GISTING · NEW</a:t>
             </a:r>
           </a:p>
           <a:p>
             <a:pPr algn="l">
               <a:lnSpc>
-                <a:spcPct val="100000"/>
-              </a:lnSpc>
-              <a:spcAft>
-                <a:spcPts val="600"/>
-              </a:spcAft>
-            </a:pPr>
-            <a:r>
-              <a:rPr sz="1100" b="0">
-                <a:solidFill>
-                  <a:srgbClr val="9FB2B6"/>
-                </a:solidFill>
-                <a:latin typeface="Consolas"/>
-              </a:rPr>
-              <a:t>fixed tokens per call</a:t>
-            </a:r>
-          </a:p>
-          <a:p>
-            <a:pPr algn="l">
-              <a:lnSpc>
                 <a:spcPct val="115000"/>
               </a:lnSpc>
               <a:spcAft>
@@ -11810,311 +11546,13 @@
               </a:spcAft>
             </a:pPr>
             <a:r>
-              <a:rPr sz="1400" b="0">
+              <a:rPr sz="1500" b="0">
                 <a:solidFill>
                   <a:srgbClr val="EEF3F3"/>
                 </a:solidFill>
                 <a:latin typeface="Calibri"/>
               </a:rPr>
-              <a:t>Learned shorthand for the preamble every call repeats: tool schemas and rules.</a:t>
-            </a:r>
-          </a:p>
-        </p:txBody>
-      </p:sp>
-      <p:sp>
-        <p:nvSpPr>
-          <p:cNvPr id="20" name="Rounded Rectangle 19"/>
-          <p:cNvSpPr/>
-          <p:nvPr/>
-        </p:nvSpPr>
-        <p:spPr>
-          <a:xfrm>
-            <a:off x="6172200" y="2743200"/>
-            <a:ext cx="2583180" cy="2651760"/>
-          </a:xfrm>
-          <a:prstGeom prst="roundRect">
-            <a:avLst>
-              <a:gd name="adj" fmla="val 6000"/>
-            </a:avLst>
-          </a:prstGeom>
-          <a:solidFill>
-            <a:srgbClr val="141D21"/>
-          </a:solidFill>
-          <a:ln w="12700">
-            <a:solidFill>
-              <a:srgbClr val="25333A"/>
-            </a:solidFill>
-          </a:ln>
-          <a:effectLst/>
-        </p:spPr>
-        <p:style>
-          <a:lnRef idx="1">
-            <a:schemeClr val="accent1"/>
-          </a:lnRef>
-          <a:fillRef idx="3">
-            <a:schemeClr val="accent1"/>
-          </a:fillRef>
-          <a:effectRef idx="2">
-            <a:schemeClr val="accent1"/>
-          </a:effectRef>
-          <a:fontRef idx="minor">
-            <a:schemeClr val="lt1"/>
-          </a:fontRef>
-        </p:style>
-        <p:txBody>
-          <a:bodyPr rtlCol="0" anchor="ctr"/>
-          <a:lstStyle/>
-          <a:p>
-            <a:pPr algn="ctr"/>
-          </a:p>
-        </p:txBody>
-      </p:sp>
-      <p:sp>
-        <p:nvSpPr>
-          <p:cNvPr id="21" name="TextBox 20"/>
-          <p:cNvSpPr txBox="1"/>
-          <p:nvPr/>
-        </p:nvSpPr>
-        <p:spPr>
-          <a:xfrm>
-            <a:off x="6428232" y="2962656"/>
-            <a:ext cx="2071116" cy="2212848"/>
-          </a:xfrm>
-          <a:prstGeom prst="rect">
-            <a:avLst/>
-          </a:prstGeom>
-          <a:noFill/>
-        </p:spPr>
-        <p:txBody>
-          <a:bodyPr wrap="square" anchor="t">
-            <a:spAutoFit/>
-          </a:bodyPr>
-          <a:lstStyle/>
-          <a:p>
-            <a:pPr algn="l">
-              <a:lnSpc>
-                <a:spcPct val="100000"/>
-              </a:lnSpc>
-              <a:spcAft>
-                <a:spcPts val="600"/>
-              </a:spcAft>
-            </a:pPr>
-            <a:r>
-              <a:rPr sz="1100" b="1">
-                <a:solidFill>
-                  <a:srgbClr val="3FB0C6"/>
-                </a:solidFill>
-                <a:latin typeface="Consolas"/>
-              </a:rPr>
-              <a:t>ADAPTIVE ROUTING</a:t>
-            </a:r>
-          </a:p>
-          <a:p>
-            <a:pPr algn="l">
-              <a:lnSpc>
-                <a:spcPct val="100000"/>
-              </a:lnSpc>
-              <a:spcAft>
-                <a:spcPts val="600"/>
-              </a:spcAft>
-            </a:pPr>
-            <a:r>
-              <a:rPr sz="1100" b="0">
-                <a:solidFill>
-                  <a:srgbClr val="9FB2B6"/>
-                </a:solidFill>
-                <a:latin typeface="Consolas"/>
-              </a:rPr>
-              <a:t>cost per token</a:t>
-            </a:r>
-          </a:p>
-          <a:p>
-            <a:pPr algn="l">
-              <a:lnSpc>
-                <a:spcPct val="115000"/>
-              </a:lnSpc>
-              <a:spcAft>
-                <a:spcPts val="0"/>
-              </a:spcAft>
-            </a:pPr>
-            <a:r>
-              <a:rPr sz="1400" b="0">
-                <a:solidFill>
-                  <a:srgbClr val="EEF3F3"/>
-                </a:solidFill>
-                <a:latin typeface="Calibri"/>
-              </a:rPr>
-              <a:t>Sends each request to the cheapest model that can handle it.</a:t>
-            </a:r>
-          </a:p>
-        </p:txBody>
-      </p:sp>
-      <p:sp>
-        <p:nvSpPr>
-          <p:cNvPr id="22" name="Rounded Rectangle 21"/>
-          <p:cNvSpPr/>
-          <p:nvPr/>
-        </p:nvSpPr>
-        <p:spPr>
-          <a:xfrm>
-            <a:off x="8938260" y="2743200"/>
-            <a:ext cx="2583180" cy="2651760"/>
-          </a:xfrm>
-          <a:prstGeom prst="roundRect">
-            <a:avLst>
-              <a:gd name="adj" fmla="val 6000"/>
-            </a:avLst>
-          </a:prstGeom>
-          <a:solidFill>
-            <a:srgbClr val="141D21"/>
-          </a:solidFill>
-          <a:ln w="12700">
-            <a:solidFill>
-              <a:srgbClr val="25333A"/>
-            </a:solidFill>
-          </a:ln>
-          <a:effectLst/>
-        </p:spPr>
-        <p:style>
-          <a:lnRef idx="1">
-            <a:schemeClr val="accent1"/>
-          </a:lnRef>
-          <a:fillRef idx="3">
-            <a:schemeClr val="accent1"/>
-          </a:fillRef>
-          <a:effectRef idx="2">
-            <a:schemeClr val="accent1"/>
-          </a:effectRef>
-          <a:fontRef idx="minor">
-            <a:schemeClr val="lt1"/>
-          </a:fontRef>
-        </p:style>
-        <p:txBody>
-          <a:bodyPr rtlCol="0" anchor="ctr"/>
-          <a:lstStyle/>
-          <a:p>
-            <a:pPr algn="ctr"/>
-          </a:p>
-        </p:txBody>
-      </p:sp>
-      <p:sp>
-        <p:nvSpPr>
-          <p:cNvPr id="23" name="TextBox 22"/>
-          <p:cNvSpPr txBox="1"/>
-          <p:nvPr/>
-        </p:nvSpPr>
-        <p:spPr>
-          <a:xfrm>
-            <a:off x="9194292" y="2962656"/>
-            <a:ext cx="2071116" cy="2212848"/>
-          </a:xfrm>
-          <a:prstGeom prst="rect">
-            <a:avLst/>
-          </a:prstGeom>
-          <a:noFill/>
-        </p:spPr>
-        <p:txBody>
-          <a:bodyPr wrap="square" anchor="t">
-            <a:spAutoFit/>
-          </a:bodyPr>
-          <a:lstStyle/>
-          <a:p>
-            <a:pPr algn="l">
-              <a:lnSpc>
-                <a:spcPct val="100000"/>
-              </a:lnSpc>
-              <a:spcAft>
-                <a:spcPts val="600"/>
-              </a:spcAft>
-            </a:pPr>
-            <a:r>
-              <a:rPr sz="1100" b="1">
-                <a:solidFill>
-                  <a:srgbClr val="3FB0C6"/>
-                </a:solidFill>
-                <a:latin typeface="Consolas"/>
-              </a:rPr>
-              <a:t>MODEL DISTILLATION</a:t>
-            </a:r>
-          </a:p>
-          <a:p>
-            <a:pPr algn="l">
-              <a:lnSpc>
-                <a:spcPct val="100000"/>
-              </a:lnSpc>
-              <a:spcAft>
-                <a:spcPts val="600"/>
-              </a:spcAft>
-            </a:pPr>
-            <a:r>
-              <a:rPr sz="1100" b="0">
-                <a:solidFill>
-                  <a:srgbClr val="9FB2B6"/>
-                </a:solidFill>
-                <a:latin typeface="Consolas"/>
-              </a:rPr>
-              <a:t>cost per token</a:t>
-            </a:r>
-          </a:p>
-          <a:p>
-            <a:pPr algn="l">
-              <a:lnSpc>
-                <a:spcPct val="115000"/>
-              </a:lnSpc>
-              <a:spcAft>
-                <a:spcPts val="0"/>
-              </a:spcAft>
-            </a:pPr>
-            <a:r>
-              <a:rPr sz="1400" b="0">
-                <a:solidFill>
-                  <a:srgbClr val="EEF3F3"/>
-                </a:solidFill>
-                <a:latin typeface="Calibri"/>
-              </a:rPr>
-              <a:t>Smaller student models for the work that allows it.</a:t>
-            </a:r>
-          </a:p>
-        </p:txBody>
-      </p:sp>
-      <p:sp>
-        <p:nvSpPr>
-          <p:cNvPr id="24" name="TextBox 23"/>
-          <p:cNvSpPr txBox="1"/>
-          <p:nvPr/>
-        </p:nvSpPr>
-        <p:spPr>
-          <a:xfrm>
-            <a:off x="640080" y="5669280"/>
-            <a:ext cx="10881360" cy="731520"/>
-          </a:xfrm>
-          <a:prstGeom prst="rect">
-            <a:avLst/>
-          </a:prstGeom>
-          <a:noFill/>
-        </p:spPr>
-        <p:txBody>
-          <a:bodyPr wrap="square" anchor="t">
-            <a:spAutoFit/>
-          </a:bodyPr>
-          <a:lstStyle/>
-          <a:p>
-            <a:pPr algn="l">
-              <a:lnSpc>
-                <a:spcPct val="115000"/>
-              </a:lnSpc>
-              <a:spcAft>
-                <a:spcPts val="0"/>
-              </a:spcAft>
-            </a:pPr>
-            <a:r>
-              <a:rPr sz="1300" b="0">
-                <a:solidFill>
-                  <a:srgbClr val="9FB2B6"/>
-                </a:solidFill>
-                <a:latin typeface="Calibri"/>
-              </a:rPr>
-              <a:t>The levers multiply rather than compete. A distilled model reached through the router still reads the full preamble on every call, unless it is gisted.</a:t>
+              <a:t>Shrinks the fixed prompt every agent call carries. This deck.</a:t>
             </a:r>
           </a:p>
         </p:txBody>
@@ -12869,7 +12307,7 @@
                 </a:solidFill>
                 <a:latin typeface="Calibri"/>
               </a:rPr>
-              <a:t>Measured on Claude Code with the Qwen tokenizer. Any harness that exposes tools pays a version of this, but its size and makeup differ, so every new pairing starts with the same span study.</a:t>
+              <a:t>Measured on Claude Code with the Qwen tokenizer. Any harness that exposes tools pays a version of this, but its size and makeup differ, so the span study is rerun for every harness and model pair.</a:t>
             </a:r>
           </a:p>
         </p:txBody>
@@ -13105,7 +12543,7 @@
                 </a:solidFill>
                 <a:latin typeface="Consolas"/>
               </a:rPr>
-              <a:t>00 · PER PAIRING</a:t>
+              <a:t>00 · PER PAIR</a:t>
             </a:r>
           </a:p>
           <a:p>
@@ -13143,7 +12581,7 @@
                 </a:solidFill>
                 <a:latin typeface="Calibri"/>
               </a:rPr>
-              <a:t>Measure what that harness re-sends, what is fixed and what is per-session, and its share of each call.</a:t>
+              <a:t>Measure what the harness re-sends on every call: what is fixed, what is per-session, and its share of each call.</a:t>
             </a:r>
           </a:p>
         </p:txBody>
@@ -13743,7 +13181,7 @@
                 </a:solidFill>
                 <a:latin typeface="Consolas"/>
               </a:rPr>
-              <a:t>PORTABLE ACROSS PAIRINGS</a:t>
+              <a:t>REUSED AS IS</a:t>
             </a:r>
           </a:p>
           <a:p>
@@ -13852,7 +13290,7 @@
                 </a:solidFill>
                 <a:latin typeface="Consolas"/>
               </a:rPr>
-              <a:t>REDONE PER PAIRING</a:t>
+              <a:t>RERUN PER PAIR</a:t>
             </a:r>
           </a:p>
           <a:p>
@@ -13871,7 +13309,7 @@
                 </a:solidFill>
                 <a:latin typeface="Calibri"/>
               </a:rPr>
-              <a:t>The span study for that harness and its tokenizer, then new rows trained for that model. Needs open weights we host; closed models get provider prompt caching instead.</a:t>
+              <a:t>The whole experiment suite, span study first, runs again for each harness and distilled-model pair. Needs a model whose weights we host.</a:t>
             </a:r>
           </a:p>
         </p:txBody>
@@ -15030,7 +14468,7 @@
                 </a:solidFill>
                 <a:latin typeface="Consolas"/>
               </a:rPr>
-              <a:t>HOW IT COMPOUNDS WITH LATTICE</a:t>
+              <a:t>SYNERGY WITHIN LATTICE · PROPOSAL</a:t>
             </a:r>
           </a:p>
         </p:txBody>
@@ -15072,7 +14510,7 @@
                 </a:solidFill>
                 <a:latin typeface="Georgia"/>
               </a:rPr>
-              <a:t>Built to plug into the other pillars</a:t>
+              <a:t>Distil first, then gist the distilled model</a:t>
             </a:r>
           </a:p>
         </p:txBody>
@@ -15085,8 +14523,8 @@
         </p:nvSpPr>
         <p:spPr>
           <a:xfrm>
-            <a:off x="640080" y="2011680"/>
-            <a:ext cx="3505200" cy="2834640"/>
+            <a:off x="640080" y="2103120"/>
+            <a:ext cx="1645920" cy="1051560"/>
           </a:xfrm>
           <a:prstGeom prst="roundRect">
             <a:avLst>
@@ -15133,8 +14571,8 @@
         </p:nvSpPr>
         <p:spPr>
           <a:xfrm>
-            <a:off x="896112" y="2231136"/>
-            <a:ext cx="2993136" cy="2395728"/>
+            <a:off x="640080" y="2103120"/>
+            <a:ext cx="1645920" cy="1051560"/>
           </a:xfrm>
           <a:prstGeom prst="rect">
             <a:avLst/>
@@ -15142,60 +14580,83 @@
           <a:noFill/>
         </p:spPr>
         <p:txBody>
-          <a:bodyPr wrap="square" anchor="t">
+          <a:bodyPr wrap="square" anchor="ctr">
             <a:spAutoFit/>
           </a:bodyPr>
           <a:lstStyle/>
           <a:p>
-            <a:pPr algn="l">
+            <a:pPr algn="ctr">
               <a:lnSpc>
                 <a:spcPct val="100000"/>
               </a:lnSpc>
               <a:spcAft>
-                <a:spcPts val="600"/>
-              </a:spcAft>
-            </a:pPr>
-            <a:r>
-              <a:rPr sz="1100" b="1">
+                <a:spcPts val="0"/>
+              </a:spcAft>
+            </a:pPr>
+            <a:r>
+              <a:rPr sz="1400" b="1">
+                <a:solidFill>
+                  <a:srgbClr val="FFFFFF"/>
+                </a:solidFill>
+                <a:latin typeface="Calibri"/>
+              </a:rPr>
+              <a:t>Base model</a:t>
+            </a:r>
+          </a:p>
+        </p:txBody>
+      </p:sp>
+      <p:sp>
+        <p:nvSpPr>
+          <p:cNvPr id="7" name="TextBox 6"/>
+          <p:cNvSpPr txBox="1"/>
+          <p:nvPr/>
+        </p:nvSpPr>
+        <p:spPr>
+          <a:xfrm>
+            <a:off x="2286000" y="2103120"/>
+            <a:ext cx="411480" cy="1051560"/>
+          </a:xfrm>
+          <a:prstGeom prst="rect">
+            <a:avLst/>
+          </a:prstGeom>
+          <a:noFill/>
+        </p:spPr>
+        <p:txBody>
+          <a:bodyPr wrap="square" anchor="ctr">
+            <a:spAutoFit/>
+          </a:bodyPr>
+          <a:lstStyle/>
+          <a:p>
+            <a:pPr algn="ctr">
+              <a:lnSpc>
+                <a:spcPct val="100000"/>
+              </a:lnSpc>
+              <a:spcAft>
+                <a:spcPts val="0"/>
+              </a:spcAft>
+            </a:pPr>
+            <a:r>
+              <a:rPr sz="2000" b="1">
                 <a:solidFill>
                   <a:srgbClr val="3FB0C6"/>
                 </a:solidFill>
-                <a:latin typeface="Consolas"/>
-              </a:rPr>
-              <a:t>META-HARNESS</a:t>
-            </a:r>
-          </a:p>
-          <a:p>
-            <a:pPr algn="l">
-              <a:lnSpc>
-                <a:spcPct val="115000"/>
-              </a:lnSpc>
-              <a:spcAft>
-                <a:spcPts val="0"/>
-              </a:spcAft>
-            </a:pPr>
-            <a:r>
-              <a:rPr sz="1500" b="0">
-                <a:solidFill>
-                  <a:srgbClr val="EEF3F3"/>
-                </a:solidFill>
                 <a:latin typeface="Calibri"/>
               </a:rPr>
-              <a:t>The adapter already sits between harness and model. The gist swap is a proxy step, so it can live there and serve every harness routed through it.</a:t>
-            </a:r>
-          </a:p>
-        </p:txBody>
-      </p:sp>
-      <p:sp>
-        <p:nvSpPr>
-          <p:cNvPr id="7" name="Rounded Rectangle 6"/>
+              <a:t>→</a:t>
+            </a:r>
+          </a:p>
+        </p:txBody>
+      </p:sp>
+      <p:sp>
+        <p:nvSpPr>
+          <p:cNvPr id="8" name="Rounded Rectangle 7"/>
           <p:cNvSpPr/>
           <p:nvPr/>
         </p:nvSpPr>
         <p:spPr>
           <a:xfrm>
-            <a:off x="4328160" y="2011680"/>
-            <a:ext cx="3505200" cy="2834640"/>
+            <a:off x="2697480" y="2103120"/>
+            <a:ext cx="1463040" cy="1051560"/>
           </a:xfrm>
           <a:prstGeom prst="roundRect">
             <a:avLst>
@@ -15236,14 +14697,14 @@
       </p:sp>
       <p:sp>
         <p:nvSpPr>
-          <p:cNvPr id="8" name="TextBox 7"/>
+          <p:cNvPr id="9" name="TextBox 8"/>
           <p:cNvSpPr txBox="1"/>
           <p:nvPr/>
         </p:nvSpPr>
         <p:spPr>
           <a:xfrm>
-            <a:off x="4584192" y="2231136"/>
-            <a:ext cx="2993136" cy="2395728"/>
+            <a:off x="2697480" y="2103120"/>
+            <a:ext cx="1463040" cy="1051560"/>
           </a:xfrm>
           <a:prstGeom prst="rect">
             <a:avLst/>
@@ -15251,60 +14712,102 @@
           <a:noFill/>
         </p:spPr>
         <p:txBody>
-          <a:bodyPr wrap="square" anchor="t">
+          <a:bodyPr wrap="square" anchor="ctr">
             <a:spAutoFit/>
           </a:bodyPr>
           <a:lstStyle/>
           <a:p>
-            <a:pPr algn="l">
+            <a:pPr algn="ctr">
               <a:lnSpc>
                 <a:spcPct val="100000"/>
               </a:lnSpc>
               <a:spcAft>
-                <a:spcPts val="600"/>
-              </a:spcAft>
-            </a:pPr>
-            <a:r>
-              <a:rPr sz="1100" b="1">
+                <a:spcPts val="0"/>
+              </a:spcAft>
+            </a:pPr>
+            <a:r>
+              <a:rPr sz="1400" b="1">
+                <a:solidFill>
+                  <a:srgbClr val="FFFFFF"/>
+                </a:solidFill>
+                <a:latin typeface="Calibri"/>
+              </a:rPr>
+              <a:t>Distil</a:t>
+            </a:r>
+          </a:p>
+          <a:p>
+            <a:pPr algn="ctr">
+              <a:lnSpc>
+                <a:spcPct val="100000"/>
+              </a:lnSpc>
+              <a:spcAft>
+                <a:spcPts val="0"/>
+              </a:spcAft>
+            </a:pPr>
+            <a:r>
+              <a:rPr sz="1000" b="0">
+                <a:solidFill>
+                  <a:srgbClr val="9FB2B6"/>
+                </a:solidFill>
+                <a:latin typeface="Consolas"/>
+              </a:rPr>
+              <a:t>distillation track</a:t>
+            </a:r>
+          </a:p>
+        </p:txBody>
+      </p:sp>
+      <p:sp>
+        <p:nvSpPr>
+          <p:cNvPr id="10" name="TextBox 9"/>
+          <p:cNvSpPr txBox="1"/>
+          <p:nvPr/>
+        </p:nvSpPr>
+        <p:spPr>
+          <a:xfrm>
+            <a:off x="4160520" y="2103120"/>
+            <a:ext cx="411480" cy="1051560"/>
+          </a:xfrm>
+          <a:prstGeom prst="rect">
+            <a:avLst/>
+          </a:prstGeom>
+          <a:noFill/>
+        </p:spPr>
+        <p:txBody>
+          <a:bodyPr wrap="square" anchor="ctr">
+            <a:spAutoFit/>
+          </a:bodyPr>
+          <a:lstStyle/>
+          <a:p>
+            <a:pPr algn="ctr">
+              <a:lnSpc>
+                <a:spcPct val="100000"/>
+              </a:lnSpc>
+              <a:spcAft>
+                <a:spcPts val="0"/>
+              </a:spcAft>
+            </a:pPr>
+            <a:r>
+              <a:rPr sz="2000" b="1">
                 <a:solidFill>
                   <a:srgbClr val="3FB0C6"/>
                 </a:solidFill>
-                <a:latin typeface="Consolas"/>
-              </a:rPr>
-              <a:t>DISTILLATION</a:t>
-            </a:r>
-          </a:p>
-          <a:p>
-            <a:pPr algn="l">
-              <a:lnSpc>
-                <a:spcPct val="115000"/>
-              </a:lnSpc>
-              <a:spcAft>
-                <a:spcPts val="0"/>
-              </a:spcAft>
-            </a:pPr>
-            <a:r>
-              <a:rPr sz="1500" b="0">
-                <a:solidFill>
-                  <a:srgbClr val="EEF3F3"/>
-                </a:solidFill>
                 <a:latin typeface="Calibri"/>
               </a:rPr>
-              <a:t>A student model still reads the full preamble on every call. The same recipe trains rows for the student: smaller model, shorter prompt.</a:t>
-            </a:r>
-          </a:p>
-        </p:txBody>
-      </p:sp>
-      <p:sp>
-        <p:nvSpPr>
-          <p:cNvPr id="9" name="Rounded Rectangle 8"/>
+              <a:t>→</a:t>
+            </a:r>
+          </a:p>
+        </p:txBody>
+      </p:sp>
+      <p:sp>
+        <p:nvSpPr>
+          <p:cNvPr id="11" name="Rounded Rectangle 10"/>
           <p:cNvSpPr/>
           <p:nvPr/>
         </p:nvSpPr>
         <p:spPr>
           <a:xfrm>
-            <a:off x="8016239" y="2011680"/>
-            <a:ext cx="3505200" cy="2834640"/>
+            <a:off x="4572000" y="2103120"/>
+            <a:ext cx="1828800" cy="1051560"/>
           </a:xfrm>
           <a:prstGeom prst="roundRect">
             <a:avLst>
@@ -15345,14 +14848,339 @@
       </p:sp>
       <p:sp>
         <p:nvSpPr>
-          <p:cNvPr id="10" name="TextBox 9"/>
+          <p:cNvPr id="12" name="TextBox 11"/>
           <p:cNvSpPr txBox="1"/>
           <p:nvPr/>
         </p:nvSpPr>
         <p:spPr>
           <a:xfrm>
-            <a:off x="8272271" y="2231136"/>
-            <a:ext cx="2993136" cy="2395728"/>
+            <a:off x="4572000" y="2103120"/>
+            <a:ext cx="1828800" cy="1051560"/>
+          </a:xfrm>
+          <a:prstGeom prst="rect">
+            <a:avLst/>
+          </a:prstGeom>
+          <a:noFill/>
+        </p:spPr>
+        <p:txBody>
+          <a:bodyPr wrap="square" anchor="ctr">
+            <a:spAutoFit/>
+          </a:bodyPr>
+          <a:lstStyle/>
+          <a:p>
+            <a:pPr algn="ctr">
+              <a:lnSpc>
+                <a:spcPct val="100000"/>
+              </a:lnSpc>
+              <a:spcAft>
+                <a:spcPts val="0"/>
+              </a:spcAft>
+            </a:pPr>
+            <a:r>
+              <a:rPr sz="1400" b="1">
+                <a:solidFill>
+                  <a:srgbClr val="FFFFFF"/>
+                </a:solidFill>
+                <a:latin typeface="Calibri"/>
+              </a:rPr>
+              <a:t>Student model</a:t>
+            </a:r>
+          </a:p>
+        </p:txBody>
+      </p:sp>
+      <p:sp>
+        <p:nvSpPr>
+          <p:cNvPr id="13" name="TextBox 12"/>
+          <p:cNvSpPr txBox="1"/>
+          <p:nvPr/>
+        </p:nvSpPr>
+        <p:spPr>
+          <a:xfrm>
+            <a:off x="6400800" y="2103120"/>
+            <a:ext cx="411480" cy="1051560"/>
+          </a:xfrm>
+          <a:prstGeom prst="rect">
+            <a:avLst/>
+          </a:prstGeom>
+          <a:noFill/>
+        </p:spPr>
+        <p:txBody>
+          <a:bodyPr wrap="square" anchor="ctr">
+            <a:spAutoFit/>
+          </a:bodyPr>
+          <a:lstStyle/>
+          <a:p>
+            <a:pPr algn="ctr">
+              <a:lnSpc>
+                <a:spcPct val="100000"/>
+              </a:lnSpc>
+              <a:spcAft>
+                <a:spcPts val="0"/>
+              </a:spcAft>
+            </a:pPr>
+            <a:r>
+              <a:rPr sz="2000" b="1">
+                <a:solidFill>
+                  <a:srgbClr val="3FB0C6"/>
+                </a:solidFill>
+                <a:latin typeface="Calibri"/>
+              </a:rPr>
+              <a:t>→</a:t>
+            </a:r>
+          </a:p>
+        </p:txBody>
+      </p:sp>
+      <p:sp>
+        <p:nvSpPr>
+          <p:cNvPr id="14" name="Rounded Rectangle 13"/>
+          <p:cNvSpPr/>
+          <p:nvPr/>
+        </p:nvSpPr>
+        <p:spPr>
+          <a:xfrm>
+            <a:off x="6812280" y="2103120"/>
+            <a:ext cx="1371600" cy="1051560"/>
+          </a:xfrm>
+          <a:prstGeom prst="roundRect">
+            <a:avLst>
+              <a:gd name="adj" fmla="val 6000"/>
+            </a:avLst>
+          </a:prstGeom>
+          <a:solidFill>
+            <a:srgbClr val="141D21"/>
+          </a:solidFill>
+          <a:ln w="12700">
+            <a:solidFill>
+              <a:srgbClr val="5A3F6E"/>
+            </a:solidFill>
+          </a:ln>
+          <a:effectLst/>
+        </p:spPr>
+        <p:style>
+          <a:lnRef idx="1">
+            <a:schemeClr val="accent1"/>
+          </a:lnRef>
+          <a:fillRef idx="3">
+            <a:schemeClr val="accent1"/>
+          </a:fillRef>
+          <a:effectRef idx="2">
+            <a:schemeClr val="accent1"/>
+          </a:effectRef>
+          <a:fontRef idx="minor">
+            <a:schemeClr val="lt1"/>
+          </a:fontRef>
+        </p:style>
+        <p:txBody>
+          <a:bodyPr rtlCol="0" anchor="ctr"/>
+          <a:lstStyle/>
+          <a:p>
+            <a:pPr algn="ctr"/>
+          </a:p>
+        </p:txBody>
+      </p:sp>
+      <p:sp>
+        <p:nvSpPr>
+          <p:cNvPr id="15" name="TextBox 14"/>
+          <p:cNvSpPr txBox="1"/>
+          <p:nvPr/>
+        </p:nvSpPr>
+        <p:spPr>
+          <a:xfrm>
+            <a:off x="6812280" y="2103120"/>
+            <a:ext cx="1371600" cy="1051560"/>
+          </a:xfrm>
+          <a:prstGeom prst="rect">
+            <a:avLst/>
+          </a:prstGeom>
+          <a:noFill/>
+        </p:spPr>
+        <p:txBody>
+          <a:bodyPr wrap="square" anchor="ctr">
+            <a:spAutoFit/>
+          </a:bodyPr>
+          <a:lstStyle/>
+          <a:p>
+            <a:pPr algn="ctr">
+              <a:lnSpc>
+                <a:spcPct val="100000"/>
+              </a:lnSpc>
+              <a:spcAft>
+                <a:spcPts val="0"/>
+              </a:spcAft>
+            </a:pPr>
+            <a:r>
+              <a:rPr sz="1400" b="1">
+                <a:solidFill>
+                  <a:srgbClr val="C39BE0"/>
+                </a:solidFill>
+                <a:latin typeface="Calibri"/>
+              </a:rPr>
+              <a:t>Gist</a:t>
+            </a:r>
+          </a:p>
+          <a:p>
+            <a:pPr algn="ctr">
+              <a:lnSpc>
+                <a:spcPct val="100000"/>
+              </a:lnSpc>
+              <a:spcAft>
+                <a:spcPts val="0"/>
+              </a:spcAft>
+            </a:pPr>
+            <a:r>
+              <a:rPr sz="1000" b="0">
+                <a:solidFill>
+                  <a:srgbClr val="9FB2B6"/>
+                </a:solidFill>
+                <a:latin typeface="Consolas"/>
+              </a:rPr>
+              <a:t>this recipe</a:t>
+            </a:r>
+          </a:p>
+        </p:txBody>
+      </p:sp>
+      <p:sp>
+        <p:nvSpPr>
+          <p:cNvPr id="16" name="TextBox 15"/>
+          <p:cNvSpPr txBox="1"/>
+          <p:nvPr/>
+        </p:nvSpPr>
+        <p:spPr>
+          <a:xfrm>
+            <a:off x="8183880" y="2103120"/>
+            <a:ext cx="411480" cy="1051560"/>
+          </a:xfrm>
+          <a:prstGeom prst="rect">
+            <a:avLst/>
+          </a:prstGeom>
+          <a:noFill/>
+        </p:spPr>
+        <p:txBody>
+          <a:bodyPr wrap="square" anchor="ctr">
+            <a:spAutoFit/>
+          </a:bodyPr>
+          <a:lstStyle/>
+          <a:p>
+            <a:pPr algn="ctr">
+              <a:lnSpc>
+                <a:spcPct val="100000"/>
+              </a:lnSpc>
+              <a:spcAft>
+                <a:spcPts val="0"/>
+              </a:spcAft>
+            </a:pPr>
+            <a:r>
+              <a:rPr sz="2000" b="1">
+                <a:solidFill>
+                  <a:srgbClr val="3FB0C6"/>
+                </a:solidFill>
+                <a:latin typeface="Calibri"/>
+              </a:rPr>
+              <a:t>→</a:t>
+            </a:r>
+          </a:p>
+        </p:txBody>
+      </p:sp>
+      <p:sp>
+        <p:nvSpPr>
+          <p:cNvPr id="17" name="Rounded Rectangle 16"/>
+          <p:cNvSpPr/>
+          <p:nvPr/>
+        </p:nvSpPr>
+        <p:spPr>
+          <a:xfrm>
+            <a:off x="8595360" y="2103120"/>
+            <a:ext cx="2377440" cy="1051560"/>
+          </a:xfrm>
+          <a:prstGeom prst="roundRect">
+            <a:avLst>
+              <a:gd name="adj" fmla="val 6000"/>
+            </a:avLst>
+          </a:prstGeom>
+          <a:solidFill>
+            <a:srgbClr val="141D21"/>
+          </a:solidFill>
+          <a:ln w="12700">
+            <a:solidFill>
+              <a:srgbClr val="25333A"/>
+            </a:solidFill>
+          </a:ln>
+          <a:effectLst/>
+        </p:spPr>
+        <p:style>
+          <a:lnRef idx="1">
+            <a:schemeClr val="accent1"/>
+          </a:lnRef>
+          <a:fillRef idx="3">
+            <a:schemeClr val="accent1"/>
+          </a:fillRef>
+          <a:effectRef idx="2">
+            <a:schemeClr val="accent1"/>
+          </a:effectRef>
+          <a:fontRef idx="minor">
+            <a:schemeClr val="lt1"/>
+          </a:fontRef>
+        </p:style>
+        <p:txBody>
+          <a:bodyPr rtlCol="0" anchor="ctr"/>
+          <a:lstStyle/>
+          <a:p>
+            <a:pPr algn="ctr"/>
+          </a:p>
+        </p:txBody>
+      </p:sp>
+      <p:sp>
+        <p:nvSpPr>
+          <p:cNvPr id="18" name="TextBox 17"/>
+          <p:cNvSpPr txBox="1"/>
+          <p:nvPr/>
+        </p:nvSpPr>
+        <p:spPr>
+          <a:xfrm>
+            <a:off x="8595360" y="2103120"/>
+            <a:ext cx="2377440" cy="1051560"/>
+          </a:xfrm>
+          <a:prstGeom prst="rect">
+            <a:avLst/>
+          </a:prstGeom>
+          <a:noFill/>
+        </p:spPr>
+        <p:txBody>
+          <a:bodyPr wrap="square" anchor="ctr">
+            <a:spAutoFit/>
+          </a:bodyPr>
+          <a:lstStyle/>
+          <a:p>
+            <a:pPr algn="ctr">
+              <a:lnSpc>
+                <a:spcPct val="100000"/>
+              </a:lnSpc>
+              <a:spcAft>
+                <a:spcPts val="0"/>
+              </a:spcAft>
+            </a:pPr>
+            <a:r>
+              <a:rPr sz="1400" b="1">
+                <a:solidFill>
+                  <a:srgbClr val="FFFFFF"/>
+                </a:solidFill>
+                <a:latin typeface="Calibri"/>
+              </a:rPr>
+              <a:t>Smaller model, shorter prompt</a:t>
+            </a:r>
+          </a:p>
+        </p:txBody>
+      </p:sp>
+      <p:sp>
+        <p:nvSpPr>
+          <p:cNvPr id="19" name="TextBox 18"/>
+          <p:cNvSpPr txBox="1"/>
+          <p:nvPr/>
+        </p:nvSpPr>
+        <p:spPr>
+          <a:xfrm>
+            <a:off x="640080" y="3566160"/>
+            <a:ext cx="10607040" cy="1188720"/>
           </a:xfrm>
           <a:prstGeom prst="rect">
             <a:avLst/>
@@ -15367,53 +15195,34 @@
           <a:p>
             <a:pPr algn="l">
               <a:lnSpc>
-                <a:spcPct val="100000"/>
-              </a:lnSpc>
-              <a:spcAft>
-                <a:spcPts val="600"/>
-              </a:spcAft>
-            </a:pPr>
-            <a:r>
-              <a:rPr sz="1100" b="1">
-                <a:solidFill>
-                  <a:srgbClr val="3FB0C6"/>
-                </a:solidFill>
-                <a:latin typeface="Consolas"/>
-              </a:rPr>
-              <a:t>ADAPTIVE ROUTING</a:t>
-            </a:r>
-          </a:p>
-          <a:p>
-            <a:pPr algn="l">
-              <a:lnSpc>
-                <a:spcPct val="115000"/>
+                <a:spcPct val="125000"/>
               </a:lnSpc>
               <a:spcAft>
                 <a:spcPts val="0"/>
               </a:spcAft>
             </a:pPr>
             <a:r>
-              <a:rPr sz="1500" b="0">
-                <a:solidFill>
-                  <a:srgbClr val="EEF3F3"/>
+              <a:rPr sz="1800" b="0">
+                <a:solidFill>
+                  <a:srgbClr val="9FB2B6"/>
                 </a:solidFill>
                 <a:latin typeface="Calibri"/>
               </a:rPr>
-              <a:t>A gisted endpoint becomes a cheaper target for the router, with the full-prompt path kept as a fallback.</a:t>
-            </a:r>
-          </a:p>
-        </p:txBody>
-      </p:sp>
-      <p:sp>
-        <p:nvSpPr>
-          <p:cNvPr id="11" name="Rounded Rectangle 10"/>
+              <a:t>A distilled student model still receives the same fixed preamble on every call. Running the gisting recipe on it attacks both costs at once: a smaller model reading a shorter prompt.</a:t>
+            </a:r>
+          </a:p>
+        </p:txBody>
+      </p:sp>
+      <p:sp>
+        <p:nvSpPr>
+          <p:cNvPr id="20" name="Rounded Rectangle 19"/>
           <p:cNvSpPr/>
           <p:nvPr/>
         </p:nvSpPr>
         <p:spPr>
           <a:xfrm>
-            <a:off x="640080" y="5166360"/>
-            <a:ext cx="3291840" cy="457200"/>
+            <a:off x="640080" y="5029200"/>
+            <a:ext cx="3108960" cy="457200"/>
           </a:xfrm>
           <a:prstGeom prst="roundRect">
             <a:avLst>
@@ -15452,14 +15261,14 @@
       </p:sp>
       <p:sp>
         <p:nvSpPr>
-          <p:cNvPr id="12" name="TextBox 11"/>
+          <p:cNvPr id="21" name="TextBox 20"/>
           <p:cNvSpPr txBox="1"/>
           <p:nvPr/>
         </p:nvSpPr>
         <p:spPr>
           <a:xfrm>
-            <a:off x="777240" y="5221224"/>
-            <a:ext cx="3108960" cy="365760"/>
+            <a:off x="777240" y="5084064"/>
+            <a:ext cx="2926079" cy="365760"/>
           </a:xfrm>
           <a:prstGeom prst="rect">
             <a:avLst/>
@@ -15487,7 +15296,7 @@
                 </a:solidFill>
                 <a:latin typeface="Consolas"/>
               </a:rPr>
-              <a:t>design fit · not yet measured</a:t>
+              <a:t>proposal · not yet tested</a:t>
             </a:r>
           </a:p>
         </p:txBody>
@@ -15591,7 +15400,7 @@
                 </a:solidFill>
                 <a:latin typeface="Consolas"/>
               </a:rPr>
-              <a:t>WHERE IT LANDS · JETSTREAM PDLC</a:t>
+              <a:t>WHERE IT COULD LAND · PROPOSAL</a:t>
             </a:r>
           </a:p>
         </p:txBody>
@@ -15633,33 +15442,73 @@
                 </a:solidFill>
                 <a:latin typeface="Georgia"/>
               </a:rPr>
-              <a:t>Coding agents on many harnesses, many models</a:t>
-            </a:r>
-          </a:p>
-        </p:txBody>
-      </p:sp>
-      <p:sp>
-        <p:nvSpPr>
-          <p:cNvPr id="5" name="Rounded Rectangle 4"/>
+              <a:t>A first home in the Jetstream inner loop</a:t>
+            </a:r>
+          </a:p>
+        </p:txBody>
+      </p:sp>
+      <p:sp>
+        <p:nvSpPr>
+          <p:cNvPr id="5" name="TextBox 4"/>
+          <p:cNvSpPr txBox="1"/>
+          <p:nvPr/>
+        </p:nvSpPr>
+        <p:spPr>
+          <a:xfrm>
+            <a:off x="640080" y="2011680"/>
+            <a:ext cx="10241280" cy="1371600"/>
+          </a:xfrm>
+          <a:prstGeom prst="rect">
+            <a:avLst/>
+          </a:prstGeom>
+          <a:noFill/>
+        </p:spPr>
+        <p:txBody>
+          <a:bodyPr wrap="square" anchor="t">
+            <a:spAutoFit/>
+          </a:bodyPr>
+          <a:lstStyle/>
+          <a:p>
+            <a:pPr algn="l">
+              <a:lnSpc>
+                <a:spcPct val="125000"/>
+              </a:lnSpc>
+              <a:spcAft>
+                <a:spcPts val="0"/>
+              </a:spcAft>
+            </a:pPr>
+            <a:r>
+              <a:rPr sz="1900" b="0">
+                <a:solidFill>
+                  <a:srgbClr val="9FB2B6"/>
+                </a:solidFill>
+                <a:latin typeface="Calibri"/>
+              </a:rPr>
+              <a:t>The Jetstream inner loop takes a ticket to a PR through coding agents on different harnesses. We propose it as the first place to trial gisting, one harness and model pair at a time.</a:t>
+            </a:r>
+          </a:p>
+        </p:txBody>
+      </p:sp>
+      <p:sp>
+        <p:nvSpPr>
+          <p:cNvPr id="6" name="Rounded Rectangle 5"/>
           <p:cNvSpPr/>
           <p:nvPr/>
         </p:nvSpPr>
         <p:spPr>
           <a:xfrm>
-            <a:off x="640080" y="2011680"/>
-            <a:ext cx="3505200" cy="2834640"/>
+            <a:off x="640080" y="3657600"/>
+            <a:ext cx="1463040" cy="457200"/>
           </a:xfrm>
           <a:prstGeom prst="roundRect">
             <a:avLst>
               <a:gd name="adj" fmla="val 6000"/>
             </a:avLst>
           </a:prstGeom>
-          <a:solidFill>
-            <a:srgbClr val="141D21"/>
-          </a:solidFill>
-          <a:ln w="15875">
+          <a:noFill/>
+          <a:ln w="12700">
             <a:solidFill>
-              <a:srgbClr val="5A3F6E"/>
+              <a:srgbClr val="5A4A24"/>
             </a:solidFill>
           </a:ln>
           <a:effectLst/>
@@ -15688,14 +15537,14 @@
       </p:sp>
       <p:sp>
         <p:nvSpPr>
-          <p:cNvPr id="6" name="TextBox 5"/>
+          <p:cNvPr id="7" name="TextBox 6"/>
           <p:cNvSpPr txBox="1"/>
           <p:nvPr/>
         </p:nvSpPr>
         <p:spPr>
           <a:xfrm>
-            <a:off x="896112" y="2231136"/>
-            <a:ext cx="2993136" cy="2395728"/>
+            <a:off x="777240" y="3712463"/>
+            <a:ext cx="1280160" cy="365760"/>
           </a:xfrm>
           <a:prstGeom prst="rect">
             <a:avLst/>
@@ -15713,85 +15562,18 @@
                 <a:spcPct val="100000"/>
               </a:lnSpc>
               <a:spcAft>
-                <a:spcPts val="600"/>
-              </a:spcAft>
-            </a:pPr>
-            <a:r>
-              <a:rPr sz="1100" b="1">
-                <a:solidFill>
-                  <a:srgbClr val="C39BE0"/>
+                <a:spcPts val="0"/>
+              </a:spcAft>
+            </a:pPr>
+            <a:r>
+              <a:rPr sz="1200" b="0">
+                <a:solidFill>
+                  <a:srgbClr val="E3B24C"/>
                 </a:solidFill>
                 <a:latin typeface="Consolas"/>
               </a:rPr>
-              <a:t>INNER LOOP · TICKET TO PR</a:t>
-            </a:r>
-          </a:p>
-          <a:p>
-            <a:pPr algn="l">
-              <a:lnSpc>
-                <a:spcPct val="115000"/>
-              </a:lnSpc>
-              <a:spcAft>
-                <a:spcPts val="0"/>
-              </a:spcAft>
-            </a:pPr>
-            <a:r>
-              <a:rPr sz="1500" b="0">
-                <a:solidFill>
-                  <a:srgbClr val="EEF3F3"/>
-                </a:solidFill>
-                <a:latin typeface="Calibri"/>
-              </a:rPr>
-              <a:t>Best fit. Many short agent steps, each re-sending the same tool preamble. The closest match to what we tested.</a:t>
-            </a:r>
-          </a:p>
-        </p:txBody>
-      </p:sp>
-      <p:sp>
-        <p:nvSpPr>
-          <p:cNvPr id="7" name="Rounded Rectangle 6"/>
-          <p:cNvSpPr/>
-          <p:nvPr/>
-        </p:nvSpPr>
-        <p:spPr>
-          <a:xfrm>
-            <a:off x="4328160" y="2011680"/>
-            <a:ext cx="3505200" cy="2834640"/>
-          </a:xfrm>
-          <a:prstGeom prst="roundRect">
-            <a:avLst>
-              <a:gd name="adj" fmla="val 6000"/>
-            </a:avLst>
-          </a:prstGeom>
-          <a:solidFill>
-            <a:srgbClr val="141D21"/>
-          </a:solidFill>
-          <a:ln w="12700">
-            <a:solidFill>
-              <a:srgbClr val="25333A"/>
-            </a:solidFill>
-          </a:ln>
-          <a:effectLst/>
-        </p:spPr>
-        <p:style>
-          <a:lnRef idx="1">
-            <a:schemeClr val="accent1"/>
-          </a:lnRef>
-          <a:fillRef idx="3">
-            <a:schemeClr val="accent1"/>
-          </a:fillRef>
-          <a:effectRef idx="2">
-            <a:schemeClr val="accent1"/>
-          </a:effectRef>
-          <a:fontRef idx="minor">
-            <a:schemeClr val="lt1"/>
-          </a:fontRef>
-        </p:style>
-        <p:txBody>
-          <a:bodyPr rtlCol="0" anchor="ctr"/>
-          <a:lstStyle/>
-          <a:p>
-            <a:pPr algn="ctr"/>
+              <a:t>proposal</a:t>
+            </a:r>
           </a:p>
         </p:txBody>
       </p:sp>
@@ -15803,8 +15585,8 @@
         </p:nvSpPr>
         <p:spPr>
           <a:xfrm>
-            <a:off x="4584192" y="2231136"/>
-            <a:ext cx="2993136" cy="2395728"/>
+            <a:off x="640080" y="4389120"/>
+            <a:ext cx="10881360" cy="731520"/>
           </a:xfrm>
           <a:prstGeom prst="rect">
             <a:avLst/>
@@ -15819,25 +15601,6 @@
           <a:p>
             <a:pPr algn="l">
               <a:lnSpc>
-                <a:spcPct val="100000"/>
-              </a:lnSpc>
-              <a:spcAft>
-                <a:spcPts val="600"/>
-              </a:spcAft>
-            </a:pPr>
-            <a:r>
-              <a:rPr sz="1100" b="1">
-                <a:solidFill>
-                  <a:srgbClr val="3FB0C6"/>
-                </a:solidFill>
-                <a:latin typeface="Consolas"/>
-              </a:rPr>
-              <a:t>OUTER LOOP · VISION, PRD, HLD</a:t>
-            </a:r>
-          </a:p>
-          <a:p>
-            <a:pPr algn="l">
-              <a:lnSpc>
                 <a:spcPct val="115000"/>
               </a:lnSpc>
               <a:spcAft>
@@ -15845,164 +15608,13 @@
               </a:spcAft>
             </a:pPr>
             <a:r>
-              <a:rPr sz="1500" b="0">
-                <a:solidFill>
-                  <a:srgbClr val="EEF3F3"/>
+              <a:rPr sz="1300" b="0">
+                <a:solidFill>
+                  <a:srgbClr val="9FB2B6"/>
                 </a:solidFill>
                 <a:latin typeface="Calibri"/>
               </a:rPr>
-              <a:t>Smaller fit. Fewer, document-heavy calls, where the fixed preamble is a smaller share of each call.</a:t>
-            </a:r>
-          </a:p>
-        </p:txBody>
-      </p:sp>
-      <p:sp>
-        <p:nvSpPr>
-          <p:cNvPr id="9" name="Rounded Rectangle 8"/>
-          <p:cNvSpPr/>
-          <p:nvPr/>
-        </p:nvSpPr>
-        <p:spPr>
-          <a:xfrm>
-            <a:off x="8016239" y="2011680"/>
-            <a:ext cx="3505200" cy="2834640"/>
-          </a:xfrm>
-          <a:prstGeom prst="roundRect">
-            <a:avLst>
-              <a:gd name="adj" fmla="val 6000"/>
-            </a:avLst>
-          </a:prstGeom>
-          <a:solidFill>
-            <a:srgbClr val="141D21"/>
-          </a:solidFill>
-          <a:ln w="12700">
-            <a:solidFill>
-              <a:srgbClr val="25333A"/>
-            </a:solidFill>
-          </a:ln>
-          <a:effectLst/>
-        </p:spPr>
-        <p:style>
-          <a:lnRef idx="1">
-            <a:schemeClr val="accent1"/>
-          </a:lnRef>
-          <a:fillRef idx="3">
-            <a:schemeClr val="accent1"/>
-          </a:fillRef>
-          <a:effectRef idx="2">
-            <a:schemeClr val="accent1"/>
-          </a:effectRef>
-          <a:fontRef idx="minor">
-            <a:schemeClr val="lt1"/>
-          </a:fontRef>
-        </p:style>
-        <p:txBody>
-          <a:bodyPr rtlCol="0" anchor="ctr"/>
-          <a:lstStyle/>
-          <a:p>
-            <a:pPr algn="ctr"/>
-          </a:p>
-        </p:txBody>
-      </p:sp>
-      <p:sp>
-        <p:nvSpPr>
-          <p:cNvPr id="10" name="TextBox 9"/>
-          <p:cNvSpPr txBox="1"/>
-          <p:nvPr/>
-        </p:nvSpPr>
-        <p:spPr>
-          <a:xfrm>
-            <a:off x="8272271" y="2231136"/>
-            <a:ext cx="2993136" cy="2395728"/>
-          </a:xfrm>
-          <a:prstGeom prst="rect">
-            <a:avLst/>
-          </a:prstGeom>
-          <a:noFill/>
-        </p:spPr>
-        <p:txBody>
-          <a:bodyPr wrap="square" anchor="t">
-            <a:spAutoFit/>
-          </a:bodyPr>
-          <a:lstStyle/>
-          <a:p>
-            <a:pPr algn="l">
-              <a:lnSpc>
-                <a:spcPct val="100000"/>
-              </a:lnSpc>
-              <a:spcAft>
-                <a:spcPts val="600"/>
-              </a:spcAft>
-            </a:pPr>
-            <a:r>
-              <a:rPr sz="1100" b="1">
-                <a:solidFill>
-                  <a:srgbClr val="3FB0C6"/>
-                </a:solidFill>
-                <a:latin typeface="Consolas"/>
-              </a:rPr>
-              <a:t>MEMORY</a:t>
-            </a:r>
-          </a:p>
-          <a:p>
-            <a:pPr algn="l">
-              <a:lnSpc>
-                <a:spcPct val="115000"/>
-              </a:lnSpc>
-              <a:spcAft>
-                <a:spcPts val="0"/>
-              </a:spcAft>
-            </a:pPr>
-            <a:r>
-              <a:rPr sz="1500" b="0">
-                <a:solidFill>
-                  <a:srgbClr val="EEF3F3"/>
-                </a:solidFill>
-                <a:latin typeface="Calibri"/>
-              </a:rPr>
-              <a:t>Complementary. Memory is session-specific, so it stays raw; gisting covers only what never changes. That boundary is the lesson from our one real failure.</a:t>
-            </a:r>
-          </a:p>
-        </p:txBody>
-      </p:sp>
-      <p:sp>
-        <p:nvSpPr>
-          <p:cNvPr id="11" name="TextBox 10"/>
-          <p:cNvSpPr txBox="1"/>
-          <p:nvPr/>
-        </p:nvSpPr>
-        <p:spPr>
-          <a:xfrm>
-            <a:off x="640080" y="5166360"/>
-            <a:ext cx="10881360" cy="731520"/>
-          </a:xfrm>
-          <a:prstGeom prst="rect">
-            <a:avLst/>
-          </a:prstGeom>
-          <a:noFill/>
-        </p:spPr>
-        <p:txBody>
-          <a:bodyPr wrap="square" anchor="t">
-            <a:spAutoFit/>
-          </a:bodyPr>
-          <a:lstStyle/>
-          <a:p>
-            <a:pPr algn="l">
-              <a:lnSpc>
-                <a:spcPct val="115000"/>
-              </a:lnSpc>
-              <a:spcAft>
-                <a:spcPts val="0"/>
-              </a:spcAft>
-            </a:pPr>
-            <a:r>
-              <a:rPr sz="1300" b="0">
-                <a:solidFill>
-                  <a:srgbClr val="9FB2B6"/>
-                </a:solidFill>
-                <a:latin typeface="Calibri"/>
-              </a:rPr>
-              <a:t>Applies to Jetstream traffic that reaches an open-weights model we host through the meta-harness. Calls to closed models keep using provider prompt caching.</a:t>
+              <a:t>Gisting applies where the agent calls a model whose weights we host.</a:t>
             </a:r>
           </a:p>
         </p:txBody>

</xml_diff>

<commit_message>
Rename the pillar to Steno (learned prompt compression) in the deck, PowerPoint and note to Srini; gisting kept once as the Shopify reference
</commit_message>
<xml_diff>
--- a/Gisting-CTO-deck.pptx
+++ b/Gisting-CTO-deck.pptx
@@ -247,7 +247,7 @@
               <c:strCache>
                 <c:ptCount val="1"/>
                 <c:pt idx="0">
-                  <c:v>gist 8:1</c:v>
+                  <c:v>Steno 8:1</c:v>
                 </c:pt>
               </c:strCache>
             </c:strRef>
@@ -3551,7 +3551,7 @@
                 </a:solidFill>
                 <a:latin typeface="Georgia"/>
               </a:rPr>
-              <a:t>Gisting: cutting the repeated prompt in agent calls</a:t>
+              <a:t>Steno: learned prompt compression for agent calls</a:t>
             </a:r>
           </a:p>
         </p:txBody>
@@ -3593,7 +3593,7 @@
                 </a:solidFill>
                 <a:latin typeface="Calibri"/>
               </a:rPr>
-              <a:t>A learned shorthand for the fixed preamble a coding agent re-sends to the model. Shown on one harness and model pair; the next step tests whether it carries to others.</a:t>
+              <a:t>A learned shorthand for the fixed preamble a coding agent re-sends to the model: the technique Shopify calls gisting. Shown on one harness and model pair; the next step tests whether it carries to others.</a:t>
             </a:r>
           </a:p>
         </p:txBody>
@@ -3800,7 +3800,7 @@
                 </a:solidFill>
                 <a:latin typeface="Georgia"/>
               </a:rPr>
-              <a:t>Make gisting a Lattice pillar</a:t>
+              <a:t>Make Steno a Lattice pillar</a:t>
             </a:r>
           </a:p>
         </p:txBody>
@@ -7699,7 +7699,7 @@
                 </a:solidFill>
                 <a:latin typeface="Consolas"/>
               </a:rPr>
-              <a:t>H100 · gist 8:1</a:t>
+              <a:t>H100 · Steno 8:1</a:t>
             </a:r>
           </a:p>
         </p:txBody>
@@ -7867,7 +7867,7 @@
                 </a:solidFill>
                 <a:latin typeface="Consolas"/>
               </a:rPr>
-              <a:t>H200 · gist 8:1</a:t>
+              <a:t>H200 · Steno 8:1</a:t>
             </a:r>
           </a:p>
         </p:txBody>
@@ -7951,7 +7951,7 @@
                 </a:solidFill>
                 <a:latin typeface="Calibri"/>
               </a:rPr>
-              <a:t>On the H100 the gist lifts peak replay output per dollar by about 44%. The H100 with the gist lands level with the H200 without it, so this does not show that a cheaper card can replace a pricier one.</a:t>
+              <a:t>On the H100 Steno lifts peak replay output per dollar by about 44%. The H100 with Steno lands level with the H200 without it, so this does not show that a cheaper card can replace a pricier one.</a:t>
             </a:r>
           </a:p>
         </p:txBody>
@@ -8097,7 +8097,7 @@
                 </a:solidFill>
                 <a:latin typeface="Georgia"/>
               </a:rPr>
-              <a:t>What to keep out of the gist</a:t>
+              <a:t>What to keep out of the compressed prompt</a:t>
             </a:r>
           </a:p>
         </p:txBody>
@@ -8229,7 +8229,7 @@
                 </a:solidFill>
                 <a:latin typeface="Consolas"/>
               </a:rPr>
-              <a:t>gist: rules + …/&lt;session-id&gt;/</a:t>
+              <a:t>Steno: rules + …/&lt;session-id&gt;/</a:t>
             </a:r>
           </a:p>
         </p:txBody>
@@ -8493,7 +8493,7 @@
                 </a:solidFill>
                 <a:latin typeface="Consolas"/>
               </a:rPr>
-              <a:t>gist: rules</a:t>
+              <a:t>Steno: rules</a:t>
             </a:r>
           </a:p>
         </p:txBody>
@@ -9992,7 +9992,7 @@
                 </a:solidFill>
                 <a:latin typeface="Calibri"/>
               </a:rPr>
-              <a:t>A new pillar under Lattice, alongside the meta-harness, adaptive routing and model distillation tracks. Gisting shortens the fixed prompt a coding agent re-sends to the model.</a:t>
+              <a:t>A new pillar under Lattice, alongside the meta-harness, adaptive routing and model distillation tracks. Steno shortens the fixed prompt a coding agent re-sends to the model.</a:t>
             </a:r>
           </a:p>
         </p:txBody>
@@ -10507,7 +10507,7 @@
                 </a:solidFill>
                 <a:latin typeface="Calibri"/>
               </a:rPr>
-              <a:t>Gisting targets serving cost by shortening repeated prompts. Short H100 replays showed higher throughput; savings per successful task are not yet proven.</a:t>
+              <a:t>Steno targets serving cost by shortening repeated prompts. Short H100 replays showed higher throughput; savings per successful task are not yet proven.</a:t>
             </a:r>
           </a:p>
         </p:txBody>
@@ -10867,7 +10867,7 @@
                 </a:solidFill>
                 <a:latin typeface="Consolas"/>
               </a:rPr>
-              <a:t>GISTING · NEW</a:t>
+              <a:t>STENO · NEW</a:t>
             </a:r>
           </a:p>
           <a:p>
@@ -11624,7 +11624,7 @@
                 </a:solidFill>
                 <a:latin typeface="Calibri"/>
               </a:rPr>
-              <a:t>Base model frozen. New gist rows trained by self-distillation. A proxy swaps them in for the fixed span.</a:t>
+              <a:t>Base model frozen. New token rows trained by self-distillation. A proxy swaps them in for the fixed span.</a:t>
             </a:r>
           </a:p>
         </p:txBody>
@@ -12441,7 +12441,7 @@
                 </a:solidFill>
                 <a:latin typeface="Calibri"/>
               </a:rPr>
-              <a:t>On the harder suite, keeping session values such as the working path out of the gist, together with retraining, brought 8:1 to 16/16, matching the full prompt on the same host. Other run conditions also changed, and one path error remained.</a:t>
+              <a:t>On the harder suite, keeping session values such as the working path out of the compressed prompt, together with retraining, brought 8:1 to 16/16, matching the full prompt on the same host. Other run conditions also changed, and one path error remained.</a:t>
             </a:r>
           </a:p>
         </p:txBody>
@@ -12830,7 +12830,7 @@
                 </a:solidFill>
                 <a:latin typeface="Calibri"/>
               </a:rPr>
-              <a:t>Threshold: twice each arm’s unloaded median latency, about 8.5 s full and 8.0 s gist. Short, fixed-output replays on one GPU class, mean of three repeats; they did not measure task quality at load or isolate prefix-cache effects. On a larger H200 the peak difference was near zero (appendix).</a:t>
+              <a:t>Threshold: twice each arm’s unloaded median latency, about 8.5 s full and 8.0 s Steno. Short, fixed-output replays on one GPU class, mean of three repeats; they did not measure task quality at load or isolate prefix-cache effects. On a larger H200 the peak difference was near zero (appendix).</a:t>
             </a:r>
           </a:p>
         </p:txBody>
@@ -12976,7 +12976,7 @@
                 </a:solidFill>
                 <a:latin typeface="Georgia"/>
               </a:rPr>
-              <a:t>Distil first, then gist the distilled model</a:t>
+              <a:t>Distil first, then apply Steno to it</a:t>
             </a:r>
           </a:p>
         </p:txBody>
@@ -13481,7 +13481,7 @@
                 </a:solidFill>
                 <a:latin typeface="Calibri"/>
               </a:rPr>
-              <a:t>Gist</a:t>
+              <a:t>Steno</a:t>
             </a:r>
           </a:p>
           <a:p>
@@ -13674,7 +13674,7 @@
                 </a:solidFill>
                 <a:latin typeface="Calibri"/>
               </a:rPr>
-              <a:t>A distilled student model still receives the fixed preamble on each call. Running the gisting recipe on it aims to reduce both model size and prompt length.</a:t>
+              <a:t>A distilled student model still receives the fixed preamble on each call. Running the Steno recipe on it aims to reduce both model size and prompt length.</a:t>
             </a:r>
           </a:p>
         </p:txBody>
@@ -13950,7 +13950,7 @@
                 </a:solidFill>
                 <a:latin typeface="Calibri"/>
               </a:rPr>
-              <a:t>The Jetstream inner loop takes a ticket to a PR through coding agents on different harnesses. We propose it as the first place to trial gisting, one harness and model pair at a time.</a:t>
+              <a:t>The Jetstream inner loop takes a ticket to a PR through coding agents on different harnesses. We propose it as the first place to trial Steno, one harness and model pair at a time.</a:t>
             </a:r>
           </a:p>
         </p:txBody>
@@ -14080,7 +14080,7 @@
                 </a:solidFill>
                 <a:latin typeface="Calibri"/>
               </a:rPr>
-              <a:t>Gisting applies where the agent calls a model whose weights we host.</a:t>
+              <a:t>Steno applies where the agent calls a model whose weights we host.</a:t>
             </a:r>
           </a:p>
         </p:txBody>

</xml_diff>

<commit_message>
Steno capability: Codex review of the five parts, capability doc with 26-item TODO list (13 P1); align deck and note part descriptions with the review
</commit_message>
<xml_diff>
--- a/Gisting-CTO-deck.pptx
+++ b/Gisting-CTO-deck.pptx
@@ -12157,7 +12157,7 @@
                 </a:solidFill>
                 <a:latin typeface="Calibri"/>
               </a:rPr>
-              <a:t>Sits in front of the model and swaps the fixed span for the Steno tokens. The agent and serving engine are unchanged.</a:t>
+              <a:t>Sits in front of the model and swaps the fixed span for the Steno tokens. No change to the agent or the engine’s code; the served model carries the new token rows and a matching chat template.</a:t>
             </a:r>
           </a:p>
         </p:txBody>
@@ -12375,7 +12375,7 @@
                 </a:solidFill>
                 <a:latin typeface="Calibri"/>
               </a:rPr>
-              <a:t>A controller that provisions a GPU, trains, serves, evaluates, syncs results and tears down, with spend guards. Most experiments after the first ran through it.</a:t>
+              <a:t>Scripts and a controller that provision a GPU, train, serve, evaluate, sync results and tear down, with spend guards. Most experiments after the first ran through it; a single end-to-end entry point is still to build.</a:t>
             </a:r>
           </a:p>
         </p:txBody>

</xml_diff>

<commit_message>
Deck and note: separate what runs today from what is built on top; proxy adopts the adapter; token parity follows the model adapter; add the real-traffic finding; provider neutrality only in the lab appendix
</commit_message>
<xml_diff>
--- a/Gisting-CTO-deck.pptx
+++ b/Gisting-CTO-deck.pptx
@@ -11468,7 +11468,7 @@
                 </a:solidFill>
                 <a:latin typeface="Calibri"/>
               </a:rPr>
-              <a:t>Most experiments after the first ran through this controller rather than by hand. The next experiment will establish what transfers to a new pair and what needs adaptation.</a:t>
+              <a:t>Most experiments after the first ran through this controller rather than by hand. The loop reaches compute through a provider-neutral interface; vast.ai is the first backend.</a:t>
             </a:r>
           </a:p>
         </p:txBody>
@@ -12763,7 +12763,7 @@
                 </a:solidFill>
                 <a:latin typeface="Georgia"/>
               </a:rPr>
-              <a:t>Five parts, built for any harness and model pair</a:t>
+              <a:t>Five parts, designed for any harness and model pair</a:t>
             </a:r>
           </a:p>
         </p:txBody>
@@ -13090,7 +13090,7 @@
                 </a:solidFill>
                 <a:latin typeface="Calibri"/>
               </a:rPr>
-              <a:t>Swaps the fixed span for the Steno tokens, using the same harness adapter. No change to the agent or the engine’s code; the served model carries the new token rows.</a:t>
+              <a:t>Swaps the fixed span for the Steno tokens and adopts the same harness adapter. No change to the agent or the engine’s code; the served model carries the new token rows.</a:t>
             </a:r>
           </a:p>
         </p:txBody>
@@ -13308,7 +13308,7 @@
                 </a:solidFill>
                 <a:latin typeface="Calibri"/>
               </a:rPr>
-              <a:t>One run spec drives the whole suite: span study first, budget and pass gates, verified teardown. Self-improving within bounds: failure triage, lessons turned into checks, gated promotion, and a next-recipe proposer a person approves.</a:t>
+              <a:t>Runs today: one run spec, span study first, budget and pass gates, verified teardown. Built on top: failure triage, lessons turned into checks, gated promotion, and a next-recipe proposer a person approves.</a:t>
             </a:r>
           </a:p>
         </p:txBody>
@@ -15213,7 +15213,7 @@
                 </a:solidFill>
                 <a:latin typeface="Calibri"/>
               </a:rPr>
-              <a:t>Pass the every-call invariance and token-parity checks on a fresh capture.</a:t>
+              <a:t>Pass the every-call invariance check on a fresh capture, then token parity once the model adapter is in.</a:t>
             </a:r>
           </a:p>
         </p:txBody>
@@ -15226,8 +15226,8 @@
         </p:nvSpPr>
         <p:spPr>
           <a:xfrm>
-            <a:off x="640080" y="5440680"/>
-            <a:ext cx="10881360" cy="731520"/>
+            <a:off x="640080" y="5349240"/>
+            <a:ext cx="10881360" cy="457200"/>
           </a:xfrm>
           <a:prstGeom prst="rect">
             <a:avLst/>
@@ -15249,7 +15249,49 @@
               </a:spcAft>
             </a:pPr>
             <a:r>
-              <a:rPr sz="1300" b="0">
+              <a:rPr sz="1500" b="0">
+                <a:solidFill>
+                  <a:srgbClr val="EEF3F3"/>
+                </a:solidFill>
+                <a:latin typeface="Calibri"/>
+              </a:rPr>
+              <a:t>Already earning its keep: on real Claude Code traffic, the every-call check caught 15 per-call differences the old rules missed.</a:t>
+            </a:r>
+          </a:p>
+        </p:txBody>
+      </p:sp>
+      <p:sp>
+        <p:nvSpPr>
+          <p:cNvPr id="25" name="TextBox 24"/>
+          <p:cNvSpPr txBox="1"/>
+          <p:nvPr/>
+        </p:nvSpPr>
+        <p:spPr>
+          <a:xfrm>
+            <a:off x="640080" y="5897880"/>
+            <a:ext cx="10881360" cy="731520"/>
+          </a:xfrm>
+          <a:prstGeom prst="rect">
+            <a:avLst/>
+          </a:prstGeom>
+          <a:noFill/>
+        </p:spPr>
+        <p:txBody>
+          <a:bodyPr wrap="square" anchor="t">
+            <a:spAutoFit/>
+          </a:bodyPr>
+          <a:lstStyle/>
+          <a:p>
+            <a:pPr algn="l">
+              <a:lnSpc>
+                <a:spcPct val="115000"/>
+              </a:lnSpc>
+              <a:spcAft>
+                <a:spcPts val="0"/>
+              </a:spcAft>
+            </a:pPr>
+            <a:r>
+              <a:rPr sz="1200" b="0">
                 <a:solidFill>
                   <a:srgbClr val="9FB2B6"/>
                 </a:solidFill>

</xml_diff>

<commit_message>
Deck: PAI byline, three-line summary, benchmark pack, loop runs the other four as stages, H200 slide shows the heavy-load gain from the uncapped runs; note aligned
</commit_message>
<xml_diff>
--- a/Gisting-CTO-deck.pptx
+++ b/Gisting-CTO-deck.pptx
@@ -3638,26 +3638,7 @@
                 </a:solidFill>
                 <a:latin typeface="Consolas"/>
               </a:rPr>
-              <a:t>Arun Menon · arumenon@paypal.com</a:t>
-            </a:r>
-          </a:p>
-          <a:p>
-            <a:pPr algn="l">
-              <a:lnSpc>
-                <a:spcPct val="100000"/>
-              </a:lnSpc>
-              <a:spcAft>
-                <a:spcPts val="0"/>
-              </a:spcAft>
-            </a:pPr>
-            <a:r>
-              <a:rPr sz="1200" b="0">
-                <a:solidFill>
-                  <a:srgbClr val="3FB0C6"/>
-                </a:solidFill>
-                <a:latin typeface="Consolas"/>
-              </a:rPr>
-              <a:t>Pair studied: Claude Code → proxy → vLLM → Qwen3.8-27B (open weights, self-hosted)</a:t>
+              <a:t>PAI</a:t>
             </a:r>
           </a:p>
         </p:txBody>
@@ -11614,7 +11595,7 @@
                 </a:solidFill>
                 <a:latin typeface="Georgia"/>
               </a:rPr>
-              <a:t>The answer in four lines</a:t>
+              <a:t>The answer in three lines</a:t>
             </a:r>
           </a:p>
         </p:txBody>
@@ -11628,7 +11609,7 @@
         <p:spPr>
           <a:xfrm>
             <a:off x="640080" y="1920240"/>
-            <a:ext cx="2583180" cy="3931920"/>
+            <a:ext cx="3505200" cy="3931920"/>
           </a:xfrm>
           <a:prstGeom prst="roundRect">
             <a:avLst>
@@ -11676,7 +11657,7 @@
         <p:spPr>
           <a:xfrm>
             <a:off x="896112" y="2139696"/>
-            <a:ext cx="2071116" cy="3493008"/>
+            <a:ext cx="2993136" cy="3493008"/>
           </a:xfrm>
           <a:prstGeom prst="rect">
             <a:avLst/>
@@ -11717,7 +11698,7 @@
               </a:spcAft>
             </a:pPr>
             <a:r>
-              <a:rPr sz="1400" b="0">
+              <a:rPr sz="1500" b="0">
                 <a:solidFill>
                   <a:srgbClr val="EEF3F3"/>
                 </a:solidFill>
@@ -11736,8 +11717,8 @@
         </p:nvSpPr>
         <p:spPr>
           <a:xfrm>
-            <a:off x="3406140" y="1920240"/>
-            <a:ext cx="2583180" cy="3931920"/>
+            <a:off x="4328160" y="1920240"/>
+            <a:ext cx="3505200" cy="3931920"/>
           </a:xfrm>
           <a:prstGeom prst="roundRect">
             <a:avLst>
@@ -11784,8 +11765,8 @@
         </p:nvSpPr>
         <p:spPr>
           <a:xfrm>
-            <a:off x="3662172" y="2139696"/>
-            <a:ext cx="2071116" cy="3493008"/>
+            <a:off x="4584192" y="2139696"/>
+            <a:ext cx="2993136" cy="3493008"/>
           </a:xfrm>
           <a:prstGeom prst="rect">
             <a:avLst/>
@@ -11826,7 +11807,7 @@
               </a:spcAft>
             </a:pPr>
             <a:r>
-              <a:rPr sz="1400" b="0">
+              <a:rPr sz="1500" b="0">
                 <a:solidFill>
                   <a:srgbClr val="EEF3F3"/>
                 </a:solidFill>
@@ -11845,8 +11826,8 @@
         </p:nvSpPr>
         <p:spPr>
           <a:xfrm>
-            <a:off x="6172200" y="1920240"/>
-            <a:ext cx="2583180" cy="3931920"/>
+            <a:off x="8016239" y="1920240"/>
+            <a:ext cx="3505200" cy="3931920"/>
           </a:xfrm>
           <a:prstGeom prst="roundRect">
             <a:avLst>
@@ -11893,8 +11874,8 @@
         </p:nvSpPr>
         <p:spPr>
           <a:xfrm>
-            <a:off x="6428232" y="2139696"/>
-            <a:ext cx="2071116" cy="3493008"/>
+            <a:off x="8272271" y="2139696"/>
+            <a:ext cx="2993136" cy="3493008"/>
           </a:xfrm>
           <a:prstGeom prst="rect">
             <a:avLst/>
@@ -11918,11 +11899,11 @@
             <a:r>
               <a:rPr sz="1100" b="1">
                 <a:solidFill>
-                  <a:srgbClr val="E3B24C"/>
+                  <a:srgbClr val="57C08A"/>
                 </a:solidFill>
                 <a:latin typeface="Consolas"/>
               </a:rPr>
-              <a:t>WHAT IT ISN’T YET</a:t>
+              <a:t>THE ASK</a:t>
             </a:r>
           </a:p>
           <a:p>
@@ -11935,116 +11916,7 @@
               </a:spcAft>
             </a:pPr>
             <a:r>
-              <a:rPr sz="1400" b="0">
-                <a:solidFill>
-                  <a:srgbClr val="EEF3F3"/>
-                </a:solidFill>
-                <a:latin typeface="Calibri"/>
-              </a:rPr>
-              <a:t>One pair, our own task suites, short replay windows. Savings per successful task are not proven, and the mechanism is still open.</a:t>
-            </a:r>
-          </a:p>
-        </p:txBody>
-      </p:sp>
-      <p:sp>
-        <p:nvSpPr>
-          <p:cNvPr id="11" name="Rounded Rectangle 10"/>
-          <p:cNvSpPr/>
-          <p:nvPr/>
-        </p:nvSpPr>
-        <p:spPr>
-          <a:xfrm>
-            <a:off x="8938260" y="1920240"/>
-            <a:ext cx="2583180" cy="3931920"/>
-          </a:xfrm>
-          <a:prstGeom prst="roundRect">
-            <a:avLst>
-              <a:gd name="adj" fmla="val 6000"/>
-            </a:avLst>
-          </a:prstGeom>
-          <a:solidFill>
-            <a:srgbClr val="141D21"/>
-          </a:solidFill>
-          <a:ln w="12700">
-            <a:solidFill>
-              <a:srgbClr val="25333A"/>
-            </a:solidFill>
-          </a:ln>
-          <a:effectLst/>
-        </p:spPr>
-        <p:style>
-          <a:lnRef idx="1">
-            <a:schemeClr val="accent1"/>
-          </a:lnRef>
-          <a:fillRef idx="3">
-            <a:schemeClr val="accent1"/>
-          </a:fillRef>
-          <a:effectRef idx="2">
-            <a:schemeClr val="accent1"/>
-          </a:effectRef>
-          <a:fontRef idx="minor">
-            <a:schemeClr val="lt1"/>
-          </a:fontRef>
-        </p:style>
-        <p:txBody>
-          <a:bodyPr rtlCol="0" anchor="ctr"/>
-          <a:lstStyle/>
-          <a:p>
-            <a:pPr algn="ctr"/>
-          </a:p>
-        </p:txBody>
-      </p:sp>
-      <p:sp>
-        <p:nvSpPr>
-          <p:cNvPr id="12" name="TextBox 11"/>
-          <p:cNvSpPr txBox="1"/>
-          <p:nvPr/>
-        </p:nvSpPr>
-        <p:spPr>
-          <a:xfrm>
-            <a:off x="9194292" y="2139696"/>
-            <a:ext cx="2071116" cy="3493008"/>
-          </a:xfrm>
-          <a:prstGeom prst="rect">
-            <a:avLst/>
-          </a:prstGeom>
-          <a:noFill/>
-        </p:spPr>
-        <p:txBody>
-          <a:bodyPr wrap="square" anchor="t">
-            <a:spAutoFit/>
-          </a:bodyPr>
-          <a:lstStyle/>
-          <a:p>
-            <a:pPr algn="l">
-              <a:lnSpc>
-                <a:spcPct val="100000"/>
-              </a:lnSpc>
-              <a:spcAft>
-                <a:spcPts val="600"/>
-              </a:spcAft>
-            </a:pPr>
-            <a:r>
-              <a:rPr sz="1100" b="1">
-                <a:solidFill>
-                  <a:srgbClr val="57C08A"/>
-                </a:solidFill>
-                <a:latin typeface="Consolas"/>
-              </a:rPr>
-              <a:t>THE ASK</a:t>
-            </a:r>
-          </a:p>
-          <a:p>
-            <a:pPr algn="l">
-              <a:lnSpc>
-                <a:spcPct val="115000"/>
-              </a:lnSpc>
-              <a:spcAft>
-                <a:spcPts val="0"/>
-              </a:spcAft>
-            </a:pPr>
-            <a:r>
-              <a:rPr sz="1400" b="0">
+              <a:rPr sz="1500" b="0">
                 <a:solidFill>
                   <a:srgbClr val="EEF3F3"/>
                 </a:solidFill>
@@ -13180,7 +13052,7 @@
                 </a:solidFill>
                 <a:latin typeface="Consolas"/>
               </a:rPr>
-              <a:t>4 · EVALUATION</a:t>
+              <a:t>4 · BENCHMARK PACK</a:t>
             </a:r>
           </a:p>
           <a:p>
@@ -13308,7 +13180,7 @@
                 </a:solidFill>
                 <a:latin typeface="Calibri"/>
               </a:rPr>
-              <a:t>Runs today: one run spec, span study first, budget and pass gates, verified teardown. Built on top: failure triage, lessons turned into checks, gated promotion, and a next-recipe proposer a person approves.</a:t>
+              <a:t>Runs the other four as stages. Runs today: one run spec, span study first, budget and pass gates, verified teardown. Built on top: failure triage, lessons turned into checks, gated promotion, and a next-recipe proposer a person approves.</a:t>
             </a:r>
           </a:p>
         </p:txBody>
@@ -16352,7 +16224,7 @@
                 </a:solidFill>
                 <a:latin typeface="Calibri"/>
               </a:rPr>
-              <a:t>Threshold: twice each arm’s unloaded median latency, about 8.5 s full and 8.0 s Steno. Short, fixed-output replays on one GPU class, mean of three repeats; they did not measure task quality at load or isolate prefix-cache effects. On a larger H200 the peak difference was near zero (next slide).</a:t>
+              <a:t>Threshold: twice each arm’s unloaded median latency, about 8.5 s full and 8.0 s Steno. Short, fixed-output replays on one GPU class, mean of three repeats; they did not measure task quality at load or isolate prefix-cache effects. On a larger H200, Steno was level at peak and ahead under heavy load (next slide).</a:t>
             </a:r>
           </a:p>
         </p:txBody>
@@ -16498,7 +16370,7 @@
                 </a:solidFill>
                 <a:latin typeface="Georgia"/>
               </a:rPr>
-              <a:t>On a larger GPU, the peak gain was near zero</a:t>
+              <a:t>On a larger GPU, the gain shows up under heavy load</a:t>
             </a:r>
           </a:p>
         </p:txBody>
@@ -16512,7 +16384,7 @@
         <p:spPr>
           <a:xfrm>
             <a:off x="640080" y="1828800"/>
-            <a:ext cx="5349240" cy="1737360"/>
+            <a:ext cx="3505200" cy="1737360"/>
           </a:xfrm>
           <a:prstGeom prst="roundRect">
             <a:avLst>
@@ -16559,8 +16431,8 @@
         </p:nvSpPr>
         <p:spPr>
           <a:xfrm>
-            <a:off x="896112" y="1993392"/>
-            <a:ext cx="4846320" cy="365760"/>
+            <a:off x="868680" y="1965960"/>
+            <a:ext cx="3048000" cy="365760"/>
           </a:xfrm>
           <a:prstGeom prst="rect">
             <a:avLst/>
@@ -16582,13 +16454,13 @@
               </a:spcAft>
             </a:pPr>
             <a:r>
-              <a:rPr sz="1100" b="1">
+              <a:rPr sz="1050" b="1">
                 <a:solidFill>
                   <a:srgbClr val="3FB0C6"/>
                 </a:solidFill>
                 <a:latin typeface="Consolas"/>
               </a:rPr>
-              <a:t>H100 NVL · 95 GB</a:t>
+              <a:t>AT EACH ARM’S PEAK</a:t>
             </a:r>
           </a:p>
         </p:txBody>
@@ -16601,8 +16473,8 @@
         </p:nvSpPr>
         <p:spPr>
           <a:xfrm>
-            <a:off x="896112" y="2423160"/>
-            <a:ext cx="2377440" cy="640080"/>
+            <a:off x="868680" y="2377440"/>
+            <a:ext cx="1645920" cy="640080"/>
           </a:xfrm>
           <a:prstGeom prst="rect">
             <a:avLst/>
@@ -16624,13 +16496,13 @@
               </a:spcAft>
             </a:pPr>
             <a:r>
-              <a:rPr sz="3200" b="1">
-                <a:solidFill>
-                  <a:srgbClr val="4A5A60"/>
+              <a:rPr sz="2800" b="1">
+                <a:solidFill>
+                  <a:srgbClr val="3FB0C6"/>
                 </a:solidFill>
                 <a:latin typeface="Consolas"/>
               </a:rPr>
-              <a:t>42.7</a:t>
+              <a:t>85.3</a:t>
             </a:r>
           </a:p>
         </p:txBody>
@@ -16643,8 +16515,8 @@
         </p:nvSpPr>
         <p:spPr>
           <a:xfrm>
-            <a:off x="896112" y="3063240"/>
-            <a:ext cx="2377440" cy="365760"/>
+            <a:off x="868680" y="3017520"/>
+            <a:ext cx="1645920" cy="365760"/>
           </a:xfrm>
           <a:prstGeom prst="rect">
             <a:avLst/>
@@ -16666,7 +16538,7 @@
               </a:spcAft>
             </a:pPr>
             <a:r>
-              <a:rPr sz="1100" b="0">
+              <a:rPr sz="1000" b="0">
                 <a:solidFill>
                   <a:srgbClr val="9FB2B6"/>
                 </a:solidFill>
@@ -16685,8 +16557,8 @@
         </p:nvSpPr>
         <p:spPr>
           <a:xfrm>
-            <a:off x="3364992" y="2423160"/>
-            <a:ext cx="2377440" cy="640080"/>
+            <a:off x="2560320" y="2377440"/>
+            <a:ext cx="1645920" cy="640080"/>
           </a:xfrm>
           <a:prstGeom prst="rect">
             <a:avLst/>
@@ -16708,13 +16580,13 @@
               </a:spcAft>
             </a:pPr>
             <a:r>
-              <a:rPr sz="3200" b="1">
+              <a:rPr sz="2800" b="1">
                 <a:solidFill>
                   <a:srgbClr val="C39BE0"/>
                 </a:solidFill>
                 <a:latin typeface="Consolas"/>
               </a:rPr>
-              <a:t>61.3</a:t>
+              <a:t>83.3</a:t>
             </a:r>
           </a:p>
         </p:txBody>
@@ -16727,8 +16599,8 @@
         </p:nvSpPr>
         <p:spPr>
           <a:xfrm>
-            <a:off x="3364992" y="3063240"/>
-            <a:ext cx="2377440" cy="365760"/>
+            <a:off x="2560320" y="3017520"/>
+            <a:ext cx="1645920" cy="365760"/>
           </a:xfrm>
           <a:prstGeom prst="rect">
             <a:avLst/>
@@ -16750,13 +16622,13 @@
               </a:spcAft>
             </a:pPr>
             <a:r>
-              <a:rPr sz="1100" b="0">
+              <a:rPr sz="1000" b="0">
                 <a:solidFill>
                   <a:srgbClr val="9FB2B6"/>
                 </a:solidFill>
                 <a:latin typeface="Consolas"/>
               </a:rPr>
-              <a:t>Steno 8:1 · +44%</a:t>
+              <a:t>Steno 8:1 · level</a:t>
             </a:r>
           </a:p>
         </p:txBody>
@@ -16769,8 +16641,8 @@
         </p:nvSpPr>
         <p:spPr>
           <a:xfrm>
-            <a:off x="6172200" y="1828800"/>
-            <a:ext cx="5349240" cy="1737360"/>
+            <a:off x="4328160" y="1828800"/>
+            <a:ext cx="3505200" cy="1737360"/>
           </a:xfrm>
           <a:prstGeom prst="roundRect">
             <a:avLst>
@@ -16782,7 +16654,7 @@
           </a:solidFill>
           <a:ln w="12700">
             <a:solidFill>
-              <a:srgbClr val="25333A"/>
+              <a:srgbClr val="5A3F6E"/>
             </a:solidFill>
           </a:ln>
           <a:effectLst/>
@@ -16817,8 +16689,8 @@
         </p:nvSpPr>
         <p:spPr>
           <a:xfrm>
-            <a:off x="6428232" y="1993392"/>
-            <a:ext cx="4846320" cy="365760"/>
+            <a:off x="4556760" y="1965960"/>
+            <a:ext cx="3048000" cy="365760"/>
           </a:xfrm>
           <a:prstGeom prst="rect">
             <a:avLst/>
@@ -16840,13 +16712,13 @@
               </a:spcAft>
             </a:pPr>
             <a:r>
-              <a:rPr sz="1100" b="1">
+              <a:rPr sz="1050" b="1">
                 <a:solidFill>
                   <a:srgbClr val="3FB0C6"/>
                 </a:solidFill>
                 <a:latin typeface="Consolas"/>
               </a:rPr>
-              <a:t>H200 NVL · 143 GB</a:t>
+              <a:t>128 SESSIONS · CAP LIFTED</a:t>
             </a:r>
           </a:p>
         </p:txBody>
@@ -16859,8 +16731,8 @@
         </p:nvSpPr>
         <p:spPr>
           <a:xfrm>
-            <a:off x="6428232" y="2423160"/>
-            <a:ext cx="2377440" cy="640080"/>
+            <a:off x="4556760" y="2377440"/>
+            <a:ext cx="1645920" cy="640080"/>
           </a:xfrm>
           <a:prstGeom prst="rect">
             <a:avLst/>
@@ -16882,13 +16754,13 @@
               </a:spcAft>
             </a:pPr>
             <a:r>
-              <a:rPr sz="3200" b="1">
-                <a:solidFill>
-                  <a:srgbClr val="3FB0C6"/>
+              <a:rPr sz="2800" b="1">
+                <a:solidFill>
+                  <a:srgbClr val="4A5A60"/>
                 </a:solidFill>
                 <a:latin typeface="Consolas"/>
               </a:rPr>
-              <a:t>85.3</a:t>
+              <a:t>47.0</a:t>
             </a:r>
           </a:p>
         </p:txBody>
@@ -16901,8 +16773,8 @@
         </p:nvSpPr>
         <p:spPr>
           <a:xfrm>
-            <a:off x="6428232" y="3063240"/>
-            <a:ext cx="2377440" cy="365760"/>
+            <a:off x="4556760" y="3017520"/>
+            <a:ext cx="1645920" cy="365760"/>
           </a:xfrm>
           <a:prstGeom prst="rect">
             <a:avLst/>
@@ -16924,7 +16796,7 @@
               </a:spcAft>
             </a:pPr>
             <a:r>
-              <a:rPr sz="1100" b="0">
+              <a:rPr sz="1000" b="0">
                 <a:solidFill>
                   <a:srgbClr val="9FB2B6"/>
                 </a:solidFill>
@@ -16943,8 +16815,8 @@
         </p:nvSpPr>
         <p:spPr>
           <a:xfrm>
-            <a:off x="8897112" y="2423160"/>
-            <a:ext cx="2377440" cy="640080"/>
+            <a:off x="6248400" y="2377440"/>
+            <a:ext cx="1645920" cy="640080"/>
           </a:xfrm>
           <a:prstGeom prst="rect">
             <a:avLst/>
@@ -16966,13 +16838,13 @@
               </a:spcAft>
             </a:pPr>
             <a:r>
-              <a:rPr sz="3200" b="1">
+              <a:rPr sz="2800" b="1">
                 <a:solidFill>
                   <a:srgbClr val="C39BE0"/>
                 </a:solidFill>
                 <a:latin typeface="Consolas"/>
               </a:rPr>
-              <a:t>83.3</a:t>
+              <a:t>80.7</a:t>
             </a:r>
           </a:p>
         </p:txBody>
@@ -16985,8 +16857,8 @@
         </p:nvSpPr>
         <p:spPr>
           <a:xfrm>
-            <a:off x="8897112" y="3063240"/>
-            <a:ext cx="2377440" cy="365760"/>
+            <a:off x="6248400" y="3017520"/>
+            <a:ext cx="1645920" cy="365760"/>
           </a:xfrm>
           <a:prstGeom prst="rect">
             <a:avLst/>
@@ -17008,27 +16880,75 @@
               </a:spcAft>
             </a:pPr>
             <a:r>
-              <a:rPr sz="1100" b="0">
+              <a:rPr sz="1000" b="0">
                 <a:solidFill>
                   <a:srgbClr val="9FB2B6"/>
                 </a:solidFill>
                 <a:latin typeface="Consolas"/>
               </a:rPr>
-              <a:t>Steno 8:1 · −2%</a:t>
-            </a:r>
-          </a:p>
-        </p:txBody>
-      </p:sp>
-      <p:sp>
-        <p:nvSpPr>
-          <p:cNvPr id="17" name="TextBox 16"/>
+              <a:t>Steno 8:1 · 1.7x</a:t>
+            </a:r>
+          </a:p>
+        </p:txBody>
+      </p:sp>
+      <p:sp>
+        <p:nvSpPr>
+          <p:cNvPr id="17" name="Rounded Rectangle 16"/>
+          <p:cNvSpPr/>
+          <p:nvPr/>
+        </p:nvSpPr>
+        <p:spPr>
+          <a:xfrm>
+            <a:off x="8016239" y="1828800"/>
+            <a:ext cx="3505200" cy="1737360"/>
+          </a:xfrm>
+          <a:prstGeom prst="roundRect">
+            <a:avLst>
+              <a:gd name="adj" fmla="val 6000"/>
+            </a:avLst>
+          </a:prstGeom>
+          <a:solidFill>
+            <a:srgbClr val="141D21"/>
+          </a:solidFill>
+          <a:ln w="12700">
+            <a:solidFill>
+              <a:srgbClr val="5A3F6E"/>
+            </a:solidFill>
+          </a:ln>
+          <a:effectLst/>
+        </p:spPr>
+        <p:style>
+          <a:lnRef idx="1">
+            <a:schemeClr val="accent1"/>
+          </a:lnRef>
+          <a:fillRef idx="3">
+            <a:schemeClr val="accent1"/>
+          </a:fillRef>
+          <a:effectRef idx="2">
+            <a:schemeClr val="accent1"/>
+          </a:effectRef>
+          <a:fontRef idx="minor">
+            <a:schemeClr val="lt1"/>
+          </a:fontRef>
+        </p:style>
+        <p:txBody>
+          <a:bodyPr rtlCol="0" anchor="ctr"/>
+          <a:lstStyle/>
+          <a:p>
+            <a:pPr algn="ctr"/>
+          </a:p>
+        </p:txBody>
+      </p:sp>
+      <p:sp>
+        <p:nvSpPr>
+          <p:cNvPr id="18" name="TextBox 17"/>
           <p:cNvSpPr txBox="1"/>
           <p:nvPr/>
         </p:nvSpPr>
         <p:spPr>
           <a:xfrm>
-            <a:off x="640080" y="3657600"/>
-            <a:ext cx="10881360" cy="365760"/>
+            <a:off x="8244839" y="1965960"/>
+            <a:ext cx="3048000" cy="365760"/>
           </a:xfrm>
           <a:prstGeom prst="rect">
             <a:avLst/>
@@ -17050,27 +16970,27 @@
               </a:spcAft>
             </a:pPr>
             <a:r>
-              <a:rPr sz="1100" b="0">
-                <a:solidFill>
-                  <a:srgbClr val="9FB2B6"/>
+              <a:rPr sz="1050" b="1">
+                <a:solidFill>
+                  <a:srgbClr val="3FB0C6"/>
                 </a:solidFill>
                 <a:latin typeface="Consolas"/>
               </a:rPr>
-              <a:t>peak replay requests per minute</a:t>
-            </a:r>
-          </a:p>
-        </p:txBody>
-      </p:sp>
-      <p:sp>
-        <p:nvSpPr>
-          <p:cNvPr id="18" name="TextBox 17"/>
+              <a:t>256 SESSIONS · CAP LIFTED</a:t>
+            </a:r>
+          </a:p>
+        </p:txBody>
+      </p:sp>
+      <p:sp>
+        <p:nvSpPr>
+          <p:cNvPr id="19" name="TextBox 18"/>
           <p:cNvSpPr txBox="1"/>
           <p:nvPr/>
         </p:nvSpPr>
         <p:spPr>
           <a:xfrm>
-            <a:off x="640080" y="4114800"/>
-            <a:ext cx="10881360" cy="1188720"/>
+            <a:off x="8244839" y="2377440"/>
+            <a:ext cx="1645920" cy="640080"/>
           </a:xfrm>
           <a:prstGeom prst="rect">
             <a:avLst/>
@@ -17085,6 +17005,216 @@
           <a:p>
             <a:pPr algn="l">
               <a:lnSpc>
+                <a:spcPct val="100000"/>
+              </a:lnSpc>
+              <a:spcAft>
+                <a:spcPts val="0"/>
+              </a:spcAft>
+            </a:pPr>
+            <a:r>
+              <a:rPr sz="2800" b="1">
+                <a:solidFill>
+                  <a:srgbClr val="4A5A60"/>
+                </a:solidFill>
+                <a:latin typeface="Consolas"/>
+              </a:rPr>
+              <a:t>46.3</a:t>
+            </a:r>
+          </a:p>
+        </p:txBody>
+      </p:sp>
+      <p:sp>
+        <p:nvSpPr>
+          <p:cNvPr id="20" name="TextBox 19"/>
+          <p:cNvSpPr txBox="1"/>
+          <p:nvPr/>
+        </p:nvSpPr>
+        <p:spPr>
+          <a:xfrm>
+            <a:off x="8244839" y="3017520"/>
+            <a:ext cx="1645920" cy="365760"/>
+          </a:xfrm>
+          <a:prstGeom prst="rect">
+            <a:avLst/>
+          </a:prstGeom>
+          <a:noFill/>
+        </p:spPr>
+        <p:txBody>
+          <a:bodyPr wrap="square" anchor="t">
+            <a:spAutoFit/>
+          </a:bodyPr>
+          <a:lstStyle/>
+          <a:p>
+            <a:pPr algn="l">
+              <a:lnSpc>
+                <a:spcPct val="100000"/>
+              </a:lnSpc>
+              <a:spcAft>
+                <a:spcPts val="0"/>
+              </a:spcAft>
+            </a:pPr>
+            <a:r>
+              <a:rPr sz="1000" b="0">
+                <a:solidFill>
+                  <a:srgbClr val="9FB2B6"/>
+                </a:solidFill>
+                <a:latin typeface="Consolas"/>
+              </a:rPr>
+              <a:t>full prompt</a:t>
+            </a:r>
+          </a:p>
+        </p:txBody>
+      </p:sp>
+      <p:sp>
+        <p:nvSpPr>
+          <p:cNvPr id="21" name="TextBox 20"/>
+          <p:cNvSpPr txBox="1"/>
+          <p:nvPr/>
+        </p:nvSpPr>
+        <p:spPr>
+          <a:xfrm>
+            <a:off x="9936479" y="2377440"/>
+            <a:ext cx="1645920" cy="640080"/>
+          </a:xfrm>
+          <a:prstGeom prst="rect">
+            <a:avLst/>
+          </a:prstGeom>
+          <a:noFill/>
+        </p:spPr>
+        <p:txBody>
+          <a:bodyPr wrap="square" anchor="t">
+            <a:spAutoFit/>
+          </a:bodyPr>
+          <a:lstStyle/>
+          <a:p>
+            <a:pPr algn="l">
+              <a:lnSpc>
+                <a:spcPct val="100000"/>
+              </a:lnSpc>
+              <a:spcAft>
+                <a:spcPts val="0"/>
+              </a:spcAft>
+            </a:pPr>
+            <a:r>
+              <a:rPr sz="2800" b="1">
+                <a:solidFill>
+                  <a:srgbClr val="C39BE0"/>
+                </a:solidFill>
+                <a:latin typeface="Consolas"/>
+              </a:rPr>
+              <a:t>56.7</a:t>
+            </a:r>
+          </a:p>
+        </p:txBody>
+      </p:sp>
+      <p:sp>
+        <p:nvSpPr>
+          <p:cNvPr id="22" name="TextBox 21"/>
+          <p:cNvSpPr txBox="1"/>
+          <p:nvPr/>
+        </p:nvSpPr>
+        <p:spPr>
+          <a:xfrm>
+            <a:off x="9936479" y="3017520"/>
+            <a:ext cx="1645920" cy="365760"/>
+          </a:xfrm>
+          <a:prstGeom prst="rect">
+            <a:avLst/>
+          </a:prstGeom>
+          <a:noFill/>
+        </p:spPr>
+        <p:txBody>
+          <a:bodyPr wrap="square" anchor="t">
+            <a:spAutoFit/>
+          </a:bodyPr>
+          <a:lstStyle/>
+          <a:p>
+            <a:pPr algn="l">
+              <a:lnSpc>
+                <a:spcPct val="100000"/>
+              </a:lnSpc>
+              <a:spcAft>
+                <a:spcPts val="0"/>
+              </a:spcAft>
+            </a:pPr>
+            <a:r>
+              <a:rPr sz="1000" b="0">
+                <a:solidFill>
+                  <a:srgbClr val="9FB2B6"/>
+                </a:solidFill>
+                <a:latin typeface="Consolas"/>
+              </a:rPr>
+              <a:t>Steno 8:1 · 1.2x</a:t>
+            </a:r>
+          </a:p>
+        </p:txBody>
+      </p:sp>
+      <p:sp>
+        <p:nvSpPr>
+          <p:cNvPr id="23" name="TextBox 22"/>
+          <p:cNvSpPr txBox="1"/>
+          <p:nvPr/>
+        </p:nvSpPr>
+        <p:spPr>
+          <a:xfrm>
+            <a:off x="640080" y="3657600"/>
+            <a:ext cx="10881360" cy="365760"/>
+          </a:xfrm>
+          <a:prstGeom prst="rect">
+            <a:avLst/>
+          </a:prstGeom>
+          <a:noFill/>
+        </p:spPr>
+        <p:txBody>
+          <a:bodyPr wrap="square" anchor="t">
+            <a:spAutoFit/>
+          </a:bodyPr>
+          <a:lstStyle/>
+          <a:p>
+            <a:pPr algn="l">
+              <a:lnSpc>
+                <a:spcPct val="100000"/>
+              </a:lnSpc>
+              <a:spcAft>
+                <a:spcPts val="0"/>
+              </a:spcAft>
+            </a:pPr>
+            <a:r>
+              <a:rPr sz="1100" b="0">
+                <a:solidFill>
+                  <a:srgbClr val="9FB2B6"/>
+                </a:solidFill>
+                <a:latin typeface="Consolas"/>
+              </a:rPr>
+              <a:t>replay requests per minute</a:t>
+            </a:r>
+          </a:p>
+        </p:txBody>
+      </p:sp>
+      <p:sp>
+        <p:nvSpPr>
+          <p:cNvPr id="24" name="TextBox 23"/>
+          <p:cNvSpPr txBox="1"/>
+          <p:nvPr/>
+        </p:nvSpPr>
+        <p:spPr>
+          <a:xfrm>
+            <a:off x="640080" y="4069080"/>
+            <a:ext cx="10881360" cy="1280160"/>
+          </a:xfrm>
+          <a:prstGeom prst="rect">
+            <a:avLst/>
+          </a:prstGeom>
+          <a:noFill/>
+        </p:spPr>
+        <p:txBody>
+          <a:bodyPr wrap="square" anchor="t">
+            <a:spAutoFit/>
+          </a:bodyPr>
+          <a:lstStyle/>
+          <a:p>
+            <a:pPr algn="l">
+              <a:lnSpc>
                 <a:spcPct val="120000"/>
               </a:lnSpc>
               <a:spcAft>
@@ -17092,27 +17222,27 @@
               </a:spcAft>
             </a:pPr>
             <a:r>
-              <a:rPr sz="1600" b="0">
+              <a:rPr sz="1500" b="0">
                 <a:solidFill>
                   <a:srgbClr val="9FB2B6"/>
                 </a:solidFill>
                 <a:latin typeface="Calibri"/>
               </a:rPr>
-              <a:t>The two are indistinguishable at peak on the H200: the full-prompt runs swung by up to 26 req/min between repeats of the same test, while Steno repeated almost exactly. Per rental dollar, the H100 with Steno and the H200 without it come out roughly even (appendix B).</a:t>
-            </a:r>
-          </a:p>
-        </p:txBody>
-      </p:sp>
-      <p:sp>
-        <p:nvSpPr>
-          <p:cNvPr id="19" name="Rounded Rectangle 18"/>
+              <a:t>At each arm’s best point the two run level. Pushed to 128 and 256 concurrent sessions with our client’s connection cap removed, the full prompt fell to about 47 req/min as the cache filled, while Steno served 1.2 to 1.7 times more. Per rental dollar, the H100 with Steno and the H200 without it come out roughly even (appendix B).</a:t>
+            </a:r>
+          </a:p>
+        </p:txBody>
+      </p:sp>
+      <p:sp>
+        <p:nvSpPr>
+          <p:cNvPr id="25" name="Rounded Rectangle 24"/>
           <p:cNvSpPr/>
           <p:nvPr/>
         </p:nvSpPr>
         <p:spPr>
           <a:xfrm>
-            <a:off x="640080" y="5486400"/>
-            <a:ext cx="4206240" cy="457200"/>
+            <a:off x="640080" y="5532120"/>
+            <a:ext cx="6766560" cy="457200"/>
           </a:xfrm>
           <a:prstGeom prst="roundRect">
             <a:avLst>
@@ -17151,14 +17281,14 @@
       </p:sp>
       <p:sp>
         <p:nvSpPr>
-          <p:cNvPr id="20" name="TextBox 19"/>
+          <p:cNvPr id="26" name="TextBox 25"/>
           <p:cNvSpPr txBox="1"/>
           <p:nvPr/>
         </p:nvSpPr>
         <p:spPr>
           <a:xfrm>
-            <a:off x="777240" y="5541264"/>
-            <a:ext cx="4023359" cy="365760"/>
+            <a:off x="777240" y="5586983"/>
+            <a:ext cx="6583680" cy="365760"/>
           </a:xfrm>
           <a:prstGeom prst="rect">
             <a:avLst/>
@@ -17186,7 +17316,7 @@
                 </a:solidFill>
                 <a:latin typeface="Consolas"/>
               </a:rPr>
-              <a:t>two repeats · H100-tuned server settings</a:t>
+              <a:t>peak: two repeats, H100-tuned settings · heavy load: one run per condition</a:t>
             </a:r>
           </a:p>
         </p:txBody>

</xml_diff>